<commit_message>
feat: Update presentation file with new content and design enhancements
</commit_message>
<xml_diff>
--- a/sawari_v3.pptx
+++ b/sawari_v3.pptx
@@ -4,6 +4,9 @@
   <p:sldMasterIdLst>
     <p:sldMasterId id="2147483648" r:id="rId1"/>
   </p:sldMasterIdLst>
+  <p:notesMasterIdLst>
+    <p:notesMasterId r:id="rId8"/>
+  </p:notesMasterIdLst>
   <p:sldIdLst>
     <p:sldId id="256" r:id="rId2"/>
     <p:sldId id="257" r:id="rId3"/>
@@ -12,10 +15,7 @@
     <p:sldId id="260" r:id="rId6"/>
     <p:sldId id="261" r:id="rId7"/>
   </p:sldIdLst>
-  <p:notesMasterIdLst>
-    <p:notesMasterId r:id="rId8"/>
-  </p:notesMasterIdLst>
-  <p:sldSz cx="9144000" cy="5143500"/>
+  <p:sldSz cx="9144000" cy="5143500" type="screen16x9"/>
   <p:notesSz cx="5143500" cy="9144000"/>
   <p:defaultTextStyle>
     <a:lvl1pPr marL="0" algn="l" defTabSz="914400" rtl="0" eaLnBrk="1" latinLnBrk="0" hangingPunct="1">
@@ -109,6 +109,11 @@
       </a:defRPr>
     </a:lvl9pPr>
   </p:defaultTextStyle>
+  <p:extLst>
+    <p:ext uri="{EFAFB233-063F-42B5-8137-9DF3F51BA10A}">
+      <p15:sldGuideLst xmlns:p15="http://schemas.microsoft.com/office/powerpoint/2012/main"/>
+    </p:ext>
+  </p:extLst>
 </p:presentation>
 </file>
 
@@ -134,234 +139,10 @@
           <a:chExt cx="0" cy="0"/>
         </a:xfrm>
       </p:grpSpPr>
-      <p:sp>
-        <p:nvSpPr>
-          <p:cNvPr id="2" name="Header Placeholder 1"/>
-          <p:cNvSpPr>
-            <a:spLocks noGrp="1"/>
-          </p:cNvSpPr>
-          <p:nvPr>
-            <p:ph type="hdr" sz="quarter"/>
-          </p:nvPr>
-        </p:nvSpPr>
-        <p:spPr>
-          <a:xfrm>
-            <a:off x="0" y="0"/>
-            <a:ext cx="2971800" cy="458788"/>
-          </a:xfrm>
-          <a:prstGeom prst="rect">
-            <a:avLst/>
-          </a:prstGeom>
-        </p:spPr>
-        <p:txBody>
-          <a:bodyPr vert="horz" lIns="91440" tIns="45720" rIns="91440" bIns="45720" rtlCol="0"/>
-          <a:lstStyle>
-            <a:lvl1pPr algn="l">
-              <a:defRPr sz="1200"/>
-            </a:lvl1pPr>
-          </a:lstStyle>
-          <a:p>
-            <a:endParaRPr lang="en-US"/>
-          </a:p>
-        </p:txBody>
-      </p:sp>
-      <p:sp>
-        <p:nvSpPr>
-          <p:cNvPr id="3" name="Date Placeholder 2"/>
-          <p:cNvSpPr>
-            <a:spLocks noGrp="1"/>
-          </p:cNvSpPr>
-          <p:nvPr>
-            <p:ph type="dt" idx="1"/>
-          </p:nvPr>
-        </p:nvSpPr>
-        <p:spPr>
-          <a:xfrm>
-            <a:off x="3884613" y="0"/>
-            <a:ext cx="2971800" cy="458788"/>
-          </a:xfrm>
-          <a:prstGeom prst="rect">
-            <a:avLst/>
-          </a:prstGeom>
-        </p:spPr>
-        <p:txBody>
-          <a:bodyPr vert="horz" lIns="91440" tIns="45720" rIns="91440" bIns="45720" rtlCol="0"/>
-          <a:lstStyle>
-            <a:lvl1pPr algn="r">
-              <a:defRPr sz="1200"/>
-            </a:lvl1pPr>
-          </a:lstStyle>
-          <a:p>
-            <a:fld id="{5282F153-3F37-0F45-9E97-73ACFA13230C}" type="datetimeFigureOut">
-              <a:rPr lang="en-US"/>
-              <a:t>7/23/19</a:t>
-            </a:fld>
-            <a:endParaRPr lang="en-US"/>
-          </a:p>
-        </p:txBody>
-      </p:sp>
-      <p:sp>
-        <p:nvSpPr>
-          <p:cNvPr id="4" name="Slide Image Placeholder 3"/>
-          <p:cNvSpPr>
-            <a:spLocks noGrp="1" noRot="1" noChangeAspect="1"/>
-          </p:cNvSpPr>
-          <p:nvPr>
-            <p:ph type="sldImg" idx="2"/>
-          </p:nvPr>
-        </p:nvSpPr>
-        <p:spPr>
-          <a:xfrm>
-            <a:off x="685800" y="1143000"/>
-            <a:ext cx="5486400" cy="3086100"/>
-          </a:xfrm>
-          <a:prstGeom prst="rect">
-            <a:avLst/>
-          </a:prstGeom>
-          <a:noFill/>
-          <a:ln w="12700">
-            <a:solidFill>
-              <a:prstClr val="black"/>
-            </a:solidFill>
-          </a:ln>
-        </p:spPr>
-        <p:txBody>
-          <a:bodyPr vert="horz" lIns="91440" tIns="45720" rIns="91440" bIns="45720" rtlCol="0" anchor="ctr"/>
-          <a:lstStyle/>
-          <a:p>
-            <a:endParaRPr lang="en-US"/>
-          </a:p>
-        </p:txBody>
-      </p:sp>
-      <p:sp>
-        <p:nvSpPr>
-          <p:cNvPr id="5" name="Notes Placeholder 4"/>
-          <p:cNvSpPr>
-            <a:spLocks noGrp="1"/>
-          </p:cNvSpPr>
-          <p:nvPr>
-            <p:ph type="body" sz="quarter" idx="3"/>
-          </p:nvPr>
-        </p:nvSpPr>
-        <p:spPr>
-          <a:xfrm>
-            <a:off x="685800" y="4400550"/>
-            <a:ext cx="5486400" cy="3600450"/>
-          </a:xfrm>
-          <a:prstGeom prst="rect">
-            <a:avLst/>
-          </a:prstGeom>
-        </p:spPr>
-        <p:txBody>
-          <a:bodyPr vert="horz" lIns="91440" tIns="45720" rIns="91440" bIns="45720" rtlCol="0"/>
-          <a:lstStyle/>
-          <a:p>
-            <a:pPr lvl="0"/>
-            <a:r>
-              <a:rPr lang="en-US"/>
-              <a:t>Click to edit Master text styles</a:t>
-            </a:r>
-          </a:p>
-          <a:p>
-            <a:pPr lvl="1"/>
-            <a:r>
-              <a:rPr lang="en-US"/>
-              <a:t>Second level</a:t>
-            </a:r>
-          </a:p>
-          <a:p>
-            <a:pPr lvl="2"/>
-            <a:r>
-              <a:rPr lang="en-US"/>
-              <a:t>Third level</a:t>
-            </a:r>
-          </a:p>
-          <a:p>
-            <a:pPr lvl="3"/>
-            <a:r>
-              <a:rPr lang="en-US"/>
-              <a:t>Fourth level</a:t>
-            </a:r>
-          </a:p>
-          <a:p>
-            <a:pPr lvl="4"/>
-            <a:r>
-              <a:rPr lang="en-US"/>
-              <a:t>Fifth level</a:t>
-            </a:r>
-          </a:p>
-        </p:txBody>
-      </p:sp>
-      <p:sp>
-        <p:nvSpPr>
-          <p:cNvPr id="6" name="Footer Placeholder 5"/>
-          <p:cNvSpPr>
-            <a:spLocks noGrp="1"/>
-          </p:cNvSpPr>
-          <p:nvPr>
-            <p:ph type="ftr" sz="quarter" idx="4"/>
-          </p:nvPr>
-        </p:nvSpPr>
-        <p:spPr>
-          <a:xfrm>
-            <a:off x="0" y="8685213"/>
-            <a:ext cx="2971800" cy="458787"/>
-          </a:xfrm>
-          <a:prstGeom prst="rect">
-            <a:avLst/>
-          </a:prstGeom>
-        </p:spPr>
-        <p:txBody>
-          <a:bodyPr vert="horz" lIns="91440" tIns="45720" rIns="91440" bIns="45720" rtlCol="0" anchor="b"/>
-          <a:lstStyle>
-            <a:lvl1pPr algn="l">
-              <a:defRPr sz="1200"/>
-            </a:lvl1pPr>
-          </a:lstStyle>
-          <a:p>
-            <a:endParaRPr lang="en-US"/>
-          </a:p>
-        </p:txBody>
-      </p:sp>
-      <p:sp>
-        <p:nvSpPr>
-          <p:cNvPr id="7" name="Slide Number Placeholder 6"/>
-          <p:cNvSpPr>
-            <a:spLocks noGrp="1"/>
-          </p:cNvSpPr>
-          <p:nvPr>
-            <p:ph type="sldNum" sz="quarter" idx="5"/>
-          </p:nvPr>
-        </p:nvSpPr>
-        <p:spPr>
-          <a:xfrm>
-            <a:off x="3884613" y="8685213"/>
-            <a:ext cx="2971800" cy="458787"/>
-          </a:xfrm>
-          <a:prstGeom prst="rect">
-            <a:avLst/>
-          </a:prstGeom>
-        </p:spPr>
-        <p:txBody>
-          <a:bodyPr vert="horz" lIns="91440" tIns="45720" rIns="91440" bIns="45720" rtlCol="0" anchor="b"/>
-          <a:lstStyle>
-            <a:lvl1pPr algn="r">
-              <a:defRPr sz="1200"/>
-            </a:lvl1pPr>
-          </a:lstStyle>
-          <a:p>
-            <a:fld id="{CE5E9CC1-C706-0F49-92D6-E571CC5EEA8F}" type="slidenum">
-              <a:rPr lang="en-US"/>
-              <a:t>‹#›</a:t>
-            </a:fld>
-            <a:endParaRPr lang="en-US"/>
-          </a:p>
-        </p:txBody>
-      </p:sp>
     </p:spTree>
     <p:extLst>
       <p:ext uri="{BB962C8B-B14F-4D97-AF65-F5344CB8AC3E}">
-        <p14:creationId xmlns:p14="http://schemas.microsoft.com/office/powerpoint/2010/main" val="1024086991"/>
+        <p14:creationId xmlns:p14="http://schemas.microsoft.com/office/powerpoint/2010/main" val="2593163790"/>
       </p:ext>
     </p:extLst>
   </p:cSld>
@@ -505,10 +286,6 @@
           <a:bodyPr/>
           <a:lstStyle/>
           <a:p>
-            <a:r>
-              <a:rPr lang="en-US" dirty="0"/>
-              <a:t/>
-            </a:r>
             <a:endParaRPr lang="en-US" dirty="0"/>
           </a:p>
         </p:txBody>
@@ -593,10 +370,6 @@
           <a:bodyPr/>
           <a:lstStyle/>
           <a:p>
-            <a:r>
-              <a:rPr lang="en-US" dirty="0"/>
-              <a:t/>
-            </a:r>
             <a:endParaRPr lang="en-US" dirty="0"/>
           </a:p>
         </p:txBody>
@@ -681,10 +454,6 @@
           <a:bodyPr/>
           <a:lstStyle/>
           <a:p>
-            <a:r>
-              <a:rPr lang="en-US" dirty="0"/>
-              <a:t/>
-            </a:r>
             <a:endParaRPr lang="en-US" dirty="0"/>
           </a:p>
         </p:txBody>
@@ -769,10 +538,6 @@
           <a:bodyPr/>
           <a:lstStyle/>
           <a:p>
-            <a:r>
-              <a:rPr lang="en-US" dirty="0"/>
-              <a:t/>
-            </a:r>
             <a:endParaRPr lang="en-US" dirty="0"/>
           </a:p>
         </p:txBody>
@@ -857,10 +622,6 @@
           <a:bodyPr/>
           <a:lstStyle/>
           <a:p>
-            <a:r>
-              <a:rPr lang="en-US" dirty="0"/>
-              <a:t/>
-            </a:r>
             <a:endParaRPr lang="en-US" dirty="0"/>
           </a:p>
         </p:txBody>
@@ -945,10 +706,6 @@
           <a:bodyPr/>
           <a:lstStyle/>
           <a:p>
-            <a:r>
-              <a:rPr lang="en-US" dirty="0"/>
-              <a:t/>
-            </a:r>
             <a:endParaRPr lang="en-US" dirty="0"/>
           </a:p>
         </p:txBody>
@@ -1022,6 +779,11 @@
 <file path=ppt/slideMasters/slideMaster1.xml><?xml version="1.0" encoding="utf-8"?>
 <p:sldMaster xmlns:a="http://schemas.openxmlformats.org/drawingml/2006/main" xmlns:r="http://schemas.openxmlformats.org/officeDocument/2006/relationships" xmlns:p="http://schemas.openxmlformats.org/presentationml/2006/main">
   <p:cSld>
+    <p:bg>
+      <p:bgRef idx="1001">
+        <a:schemeClr val="bg1"/>
+      </p:bgRef>
+    </p:bg>
     <p:spTree>
       <p:nvGrpSpPr>
         <p:cNvPr id="1" name=""/>
@@ -1304,6 +1066,7 @@
         <a:solidFill>
           <a:srgbClr val="FFFFFF"/>
         </a:solidFill>
+        <a:effectLst/>
       </p:bgPr>
     </p:bg>
     <p:spTree>
@@ -1344,6 +1107,13 @@
             <a:prstDash val="solid"/>
           </a:ln>
         </p:spPr>
+        <p:txBody>
+          <a:bodyPr/>
+          <a:lstStyle/>
+          <a:p>
+            <a:endParaRPr lang="en-US"/>
+          </a:p>
+        </p:txBody>
       </p:sp>
       <p:sp>
         <p:nvSpPr>
@@ -1369,6 +1139,13 @@
             <a:prstDash val="solid"/>
           </a:ln>
         </p:spPr>
+        <p:txBody>
+          <a:bodyPr/>
+          <a:lstStyle/>
+          <a:p>
+            <a:endParaRPr lang="en-US"/>
+          </a:p>
+        </p:txBody>
       </p:sp>
       <p:sp>
         <p:nvSpPr>
@@ -1391,11 +1168,11 @@
           <a:bodyPr wrap="square" lIns="0" tIns="0" rIns="0" bIns="0" rtlCol="0" anchor="ctr"/>
           <a:lstStyle/>
           <a:p>
-            <a:pPr indent="0" marL="0">
-              <a:buNone/>
-            </a:pPr>
-            <a:r>
-              <a:rPr lang="en-US" sz="850" b="1" spc="300" kern="0" dirty="0">
+            <a:pPr marL="0" indent="0">
+              <a:buNone/>
+            </a:pPr>
+            <a:r>
+              <a:rPr lang="en-US" sz="850" b="1" kern="0" spc="300" dirty="0">
                 <a:solidFill>
                   <a:srgbClr val="888888"/>
                 </a:solidFill>
@@ -1430,7 +1207,7 @@
           <a:bodyPr wrap="square" lIns="0" tIns="0" rIns="0" bIns="0" rtlCol="0" anchor="ctr"/>
           <a:lstStyle/>
           <a:p>
-            <a:pPr indent="0" marL="0">
+            <a:pPr marL="0" indent="0">
               <a:buNone/>
             </a:pPr>
             <a:r>
@@ -1469,7 +1246,7 @@
           <a:bodyPr wrap="square" lIns="0" tIns="0" rIns="0" bIns="0" rtlCol="0" anchor="ctr"/>
           <a:lstStyle/>
           <a:p>
-            <a:pPr indent="0" marL="0">
+            <a:pPr marL="0" indent="0">
               <a:buNone/>
             </a:pPr>
             <a:r>
@@ -1508,7 +1285,7 @@
           <a:bodyPr wrap="square" lIns="0" tIns="0" rIns="0" bIns="0" rtlCol="0" anchor="ctr"/>
           <a:lstStyle/>
           <a:p>
-            <a:pPr indent="0" marL="0">
+            <a:pPr marL="0" indent="0">
               <a:buNone/>
             </a:pPr>
             <a:r>
@@ -1525,7 +1302,7 @@
             <a:endParaRPr lang="en-US" sz="1500" dirty="0"/>
           </a:p>
           <a:p>
-            <a:pPr indent="0" marL="0">
+            <a:pPr marL="0" indent="0">
               <a:buNone/>
             </a:pPr>
             <a:r>
@@ -1567,6 +1344,13 @@
             <a:prstDash val="solid"/>
           </a:ln>
         </p:spPr>
+        <p:txBody>
+          <a:bodyPr/>
+          <a:lstStyle/>
+          <a:p>
+            <a:endParaRPr lang="en-US"/>
+          </a:p>
+        </p:txBody>
       </p:sp>
       <p:sp>
         <p:nvSpPr>
@@ -1577,21 +1361,32 @@
         <p:spPr>
           <a:xfrm>
             <a:off x="502920" y="4315968"/>
-            <a:ext cx="4572000" cy="347472"/>
-          </a:xfrm>
-          <a:prstGeom prst="rect">
-            <a:avLst/>
-          </a:prstGeom>
-          <a:noFill/>
-          <a:ln/>
-        </p:spPr>
-        <p:txBody>
-          <a:bodyPr wrap="square" lIns="0" tIns="0" rIns="0" bIns="0" rtlCol="0" anchor="ctr"/>
-          <a:lstStyle/>
-          <a:p>
-            <a:pPr indent="0" marL="0">
-              <a:buNone/>
-            </a:pPr>
+            <a:ext cx="4572000" cy="521208"/>
+          </a:xfrm>
+          <a:prstGeom prst="rect">
+            <a:avLst/>
+          </a:prstGeom>
+          <a:noFill/>
+          <a:ln/>
+        </p:spPr>
+        <p:txBody>
+          <a:bodyPr wrap="square" lIns="0" tIns="0" rIns="0" bIns="0" rtlCol="0" anchor="ctr"/>
+          <a:lstStyle/>
+          <a:p>
+            <a:pPr marL="0" indent="0">
+              <a:buNone/>
+            </a:pPr>
+            <a:r>
+              <a:rPr lang="en-US" sz="1100" dirty="0" err="1">
+                <a:solidFill>
+                  <a:srgbClr val="888888"/>
+                </a:solidFill>
+                <a:latin typeface="Calibri" pitchFamily="34" charset="0"/>
+                <a:ea typeface="Calibri" pitchFamily="34" charset="-122"/>
+                <a:cs typeface="Calibri" pitchFamily="34" charset="-120"/>
+              </a:rPr>
+              <a:t>Sakshyam</a:t>
+            </a:r>
             <a:r>
               <a:rPr lang="en-US" sz="1100" dirty="0">
                 <a:solidFill>
@@ -1601,7 +1396,88 @@
                 <a:ea typeface="Calibri" pitchFamily="34" charset="-122"/>
                 <a:cs typeface="Calibri" pitchFamily="34" charset="-120"/>
               </a:rPr>
-              <a:t>Zenith Kandel  ·  Presenter</a:t>
+              <a:t> </a:t>
+            </a:r>
+            <a:r>
+              <a:rPr lang="en-US" sz="1100" dirty="0" err="1">
+                <a:solidFill>
+                  <a:srgbClr val="888888"/>
+                </a:solidFill>
+                <a:latin typeface="Calibri" pitchFamily="34" charset="0"/>
+                <a:ea typeface="Calibri" pitchFamily="34" charset="-122"/>
+                <a:cs typeface="Calibri" pitchFamily="34" charset="-120"/>
+              </a:rPr>
+              <a:t>Bastakoti</a:t>
+            </a:r>
+            <a:endParaRPr lang="en-US" sz="1100" dirty="0">
+              <a:solidFill>
+                <a:srgbClr val="888888"/>
+              </a:solidFill>
+              <a:latin typeface="Calibri" pitchFamily="34" charset="0"/>
+              <a:ea typeface="Calibri" pitchFamily="34" charset="-122"/>
+              <a:cs typeface="Calibri" pitchFamily="34" charset="-120"/>
+            </a:endParaRPr>
+          </a:p>
+          <a:p>
+            <a:pPr marL="0" indent="0">
+              <a:buNone/>
+            </a:pPr>
+            <a:r>
+              <a:rPr lang="en-US" sz="1100" dirty="0" err="1">
+                <a:solidFill>
+                  <a:srgbClr val="888888"/>
+                </a:solidFill>
+                <a:latin typeface="Calibri" pitchFamily="34" charset="0"/>
+                <a:ea typeface="Calibri" pitchFamily="34" charset="-122"/>
+                <a:cs typeface="Calibri" pitchFamily="34" charset="-120"/>
+              </a:rPr>
+              <a:t>Sakshyam</a:t>
+            </a:r>
+            <a:r>
+              <a:rPr lang="en-US" sz="1100" dirty="0">
+                <a:solidFill>
+                  <a:srgbClr val="888888"/>
+                </a:solidFill>
+                <a:latin typeface="Calibri" pitchFamily="34" charset="0"/>
+                <a:ea typeface="Calibri" pitchFamily="34" charset="-122"/>
+                <a:cs typeface="Calibri" pitchFamily="34" charset="-120"/>
+              </a:rPr>
+              <a:t> </a:t>
+            </a:r>
+            <a:r>
+              <a:rPr lang="en-US" sz="1100" dirty="0" err="1">
+                <a:solidFill>
+                  <a:srgbClr val="888888"/>
+                </a:solidFill>
+                <a:latin typeface="Calibri" pitchFamily="34" charset="0"/>
+                <a:ea typeface="Calibri" pitchFamily="34" charset="-122"/>
+                <a:cs typeface="Calibri" pitchFamily="34" charset="-120"/>
+              </a:rPr>
+              <a:t>Upadhaya</a:t>
+            </a:r>
+            <a:endParaRPr lang="en-US" sz="1100" dirty="0">
+              <a:solidFill>
+                <a:srgbClr val="888888"/>
+              </a:solidFill>
+              <a:latin typeface="Calibri" pitchFamily="34" charset="0"/>
+              <a:ea typeface="Calibri" pitchFamily="34" charset="-122"/>
+              <a:cs typeface="Calibri" pitchFamily="34" charset="-120"/>
+            </a:endParaRPr>
+          </a:p>
+          <a:p>
+            <a:pPr marL="0" indent="0">
+              <a:buNone/>
+            </a:pPr>
+            <a:r>
+              <a:rPr lang="en-US" sz="1100" dirty="0">
+                <a:solidFill>
+                  <a:srgbClr val="888888"/>
+                </a:solidFill>
+                <a:latin typeface="Calibri" pitchFamily="34" charset="0"/>
+                <a:ea typeface="Calibri" pitchFamily="34" charset="-122"/>
+                <a:cs typeface="Calibri" pitchFamily="34" charset="-120"/>
+              </a:rPr>
+              <a:t>Zenith Kandel</a:t>
             </a:r>
             <a:endParaRPr lang="en-US" sz="1100" dirty="0"/>
           </a:p>
@@ -1609,7 +1485,7 @@
       </p:sp>
       <p:sp>
         <p:nvSpPr>
-          <p:cNvPr id="10" name="Shape 8"/>
+          <p:cNvPr id="11" name="Text 9"/>
           <p:cNvSpPr/>
           <p:nvPr/>
         </p:nvSpPr>
@@ -1621,73 +1497,83 @@
           <a:prstGeom prst="rect">
             <a:avLst/>
           </a:prstGeom>
-          <a:solidFill>
-            <a:srgbClr val="F7F7F5"/>
-          </a:solidFill>
-          <a:ln w="9525">
+          <a:noFill/>
+          <a:ln/>
+        </p:spPr>
+        <p:txBody>
+          <a:bodyPr wrap="square" lIns="0" tIns="0" rIns="0" bIns="0" rtlCol="0" anchor="ctr"/>
+          <a:lstStyle/>
+          <a:p>
+            <a:pPr marL="0" indent="0" algn="ctr">
+              <a:buNone/>
+            </a:pPr>
+            <a:r>
+              <a:rPr lang="en-US" sz="900" dirty="0">
+                <a:solidFill>
+                  <a:srgbClr val="888888"/>
+                </a:solidFill>
+                <a:latin typeface="Calibri" pitchFamily="34" charset="0"/>
+                <a:ea typeface="Calibri" pitchFamily="34" charset="-122"/>
+                <a:cs typeface="Calibri" pitchFamily="34" charset="-120"/>
+              </a:rPr>
+              <a:t>App screenshot</a:t>
+            </a:r>
+            <a:endParaRPr lang="en-US" sz="900" dirty="0"/>
+          </a:p>
+          <a:p>
+            <a:pPr marL="0" indent="0" algn="ctr">
+              <a:buNone/>
+            </a:pPr>
+            <a:r>
+              <a:rPr lang="en-US" sz="900" dirty="0">
+                <a:solidFill>
+                  <a:srgbClr val="888888"/>
+                </a:solidFill>
+                <a:latin typeface="Calibri" pitchFamily="34" charset="0"/>
+                <a:ea typeface="Calibri" pitchFamily="34" charset="-122"/>
+                <a:cs typeface="Calibri" pitchFamily="34" charset="-120"/>
+              </a:rPr>
+              <a:t>(map + route result)</a:t>
+            </a:r>
+            <a:endParaRPr lang="en-US" sz="900" dirty="0"/>
+          </a:p>
+        </p:txBody>
+      </p:sp>
+      <p:pic>
+        <p:nvPicPr>
+          <p:cNvPr id="13" name="Picture 12">
+            <a:extLst>
+              <a:ext uri="{FF2B5EF4-FFF2-40B4-BE49-F238E27FC236}">
+                <a16:creationId xmlns:a16="http://schemas.microsoft.com/office/drawing/2014/main" id="{5D3C1ABC-039C-4AEA-CA28-410B57A7489D}"/>
+              </a:ext>
+            </a:extLst>
+          </p:cNvPr>
+          <p:cNvPicPr>
+            <a:picLocks noChangeAspect="1"/>
+          </p:cNvPicPr>
+          <p:nvPr/>
+        </p:nvPicPr>
+        <p:blipFill>
+          <a:blip r:embed="rId3"/>
+          <a:stretch>
+            <a:fillRect/>
+          </a:stretch>
+        </p:blipFill>
+        <p:spPr>
+          <a:xfrm>
+            <a:off x="6644983" y="632294"/>
+            <a:ext cx="1797633" cy="3413926"/>
+          </a:xfrm>
+          <a:prstGeom prst="rect">
+            <a:avLst/>
+          </a:prstGeom>
+          <a:ln w="57150">
             <a:solidFill>
-              <a:srgbClr val="E0E0DC"/>
+              <a:schemeClr val="tx1"/>
             </a:solidFill>
-            <a:prstDash val="solid"/>
           </a:ln>
         </p:spPr>
-      </p:sp>
-      <p:sp>
-        <p:nvSpPr>
-          <p:cNvPr id="11" name="Text 9"/>
-          <p:cNvSpPr/>
-          <p:nvPr/>
-        </p:nvSpPr>
-        <p:spPr>
-          <a:xfrm>
-            <a:off x="6217920" y="594360"/>
-            <a:ext cx="2651760" cy="3337560"/>
-          </a:xfrm>
-          <a:prstGeom prst="rect">
-            <a:avLst/>
-          </a:prstGeom>
-          <a:noFill/>
-          <a:ln/>
-        </p:spPr>
-        <p:txBody>
-          <a:bodyPr wrap="square" lIns="0" tIns="0" rIns="0" bIns="0" rtlCol="0" anchor="ctr"/>
-          <a:lstStyle/>
-          <a:p>
-            <a:pPr algn="ctr" indent="0" marL="0">
-              <a:buNone/>
-            </a:pPr>
-            <a:r>
-              <a:rPr lang="en-US" sz="900" dirty="0">
-                <a:solidFill>
-                  <a:srgbClr val="888888"/>
-                </a:solidFill>
-                <a:latin typeface="Calibri" pitchFamily="34" charset="0"/>
-                <a:ea typeface="Calibri" pitchFamily="34" charset="-122"/>
-                <a:cs typeface="Calibri" pitchFamily="34" charset="-120"/>
-              </a:rPr>
-              <a:t>App screenshot</a:t>
-            </a:r>
-            <a:endParaRPr lang="en-US" sz="900" dirty="0"/>
-          </a:p>
-          <a:p>
-            <a:pPr algn="ctr" indent="0" marL="0">
-              <a:buNone/>
-            </a:pPr>
-            <a:r>
-              <a:rPr lang="en-US" sz="900" dirty="0">
-                <a:solidFill>
-                  <a:srgbClr val="888888"/>
-                </a:solidFill>
-                <a:latin typeface="Calibri" pitchFamily="34" charset="0"/>
-                <a:ea typeface="Calibri" pitchFamily="34" charset="-122"/>
-                <a:cs typeface="Calibri" pitchFamily="34" charset="-120"/>
-              </a:rPr>
-              <a:t>(map + route result)</a:t>
-            </a:r>
-            <a:endParaRPr lang="en-US" sz="900" dirty="0"/>
-          </a:p>
-        </p:txBody>
-      </p:sp>
+      </p:pic>
     </p:spTree>
   </p:cSld>
   <p:clrMapOvr>
@@ -1704,6 +1590,7 @@
         <a:solidFill>
           <a:srgbClr val="FFFFFF"/>
         </a:solidFill>
+        <a:effectLst/>
       </p:bgPr>
     </p:bg>
     <p:spTree>
@@ -1744,6 +1631,13 @@
             <a:prstDash val="solid"/>
           </a:ln>
         </p:spPr>
+        <p:txBody>
+          <a:bodyPr/>
+          <a:lstStyle/>
+          <a:p>
+            <a:endParaRPr lang="en-US"/>
+          </a:p>
+        </p:txBody>
       </p:sp>
       <p:sp>
         <p:nvSpPr>
@@ -1769,6 +1663,13 @@
             <a:prstDash val="solid"/>
           </a:ln>
         </p:spPr>
+        <p:txBody>
+          <a:bodyPr/>
+          <a:lstStyle/>
+          <a:p>
+            <a:endParaRPr lang="en-US"/>
+          </a:p>
+        </p:txBody>
       </p:sp>
       <p:sp>
         <p:nvSpPr>
@@ -1791,11 +1692,11 @@
           <a:bodyPr wrap="square" lIns="0" tIns="0" rIns="0" bIns="0" rtlCol="0" anchor="ctr"/>
           <a:lstStyle/>
           <a:p>
-            <a:pPr indent="0" marL="0">
-              <a:buNone/>
-            </a:pPr>
-            <a:r>
-              <a:rPr lang="en-US" sz="850" b="1" spc="300" kern="0" dirty="0">
+            <a:pPr marL="0" indent="0">
+              <a:buNone/>
+            </a:pPr>
+            <a:r>
+              <a:rPr lang="en-US" sz="850" b="1" kern="0" spc="300" dirty="0">
                 <a:solidFill>
                   <a:srgbClr val="888888"/>
                 </a:solidFill>
@@ -1830,7 +1731,7 @@
           <a:bodyPr wrap="square" lIns="0" tIns="0" rIns="0" bIns="0" rtlCol="0" anchor="ctr"/>
           <a:lstStyle/>
           <a:p>
-            <a:pPr indent="0" marL="0">
+            <a:pPr marL="0" indent="0">
               <a:buNone/>
             </a:pPr>
             <a:r>
@@ -1847,7 +1748,7 @@
             <a:endParaRPr lang="en-US" sz="3800" dirty="0"/>
           </a:p>
           <a:p>
-            <a:pPr indent="0" marL="0">
+            <a:pPr marL="0" indent="0">
               <a:buNone/>
             </a:pPr>
             <a:r>
@@ -1889,6 +1790,13 @@
             <a:prstDash val="solid"/>
           </a:ln>
         </p:spPr>
+        <p:txBody>
+          <a:bodyPr/>
+          <a:lstStyle/>
+          <a:p>
+            <a:endParaRPr lang="en-US"/>
+          </a:p>
+        </p:txBody>
       </p:sp>
       <p:sp>
         <p:nvSpPr>
@@ -1911,7 +1819,7 @@
           <a:bodyPr wrap="square" lIns="0" tIns="0" rIns="0" bIns="0" rtlCol="0" anchor="ctr"/>
           <a:lstStyle/>
           <a:p>
-            <a:pPr indent="0" marL="0">
+            <a:pPr marL="0" indent="0">
               <a:buNone/>
             </a:pPr>
             <a:r>
@@ -1950,7 +1858,7 @@
           <a:bodyPr wrap="square" lIns="0" tIns="0" rIns="0" bIns="0" rtlCol="0" anchor="ctr"/>
           <a:lstStyle/>
           <a:p>
-            <a:pPr indent="0" marL="0">
+            <a:pPr marL="0" indent="0">
               <a:buNone/>
             </a:pPr>
             <a:r>
@@ -1989,7 +1897,7 @@
           <a:bodyPr wrap="square" lIns="0" tIns="0" rIns="0" bIns="0" rtlCol="0" anchor="ctr"/>
           <a:lstStyle/>
           <a:p>
-            <a:pPr indent="0" marL="0">
+            <a:pPr marL="0" indent="0">
               <a:buNone/>
             </a:pPr>
             <a:r>
@@ -2028,7 +1936,7 @@
           <a:bodyPr wrap="square" lIns="0" tIns="0" rIns="0" bIns="0" rtlCol="0" anchor="ctr"/>
           <a:lstStyle/>
           <a:p>
-            <a:pPr indent="0" marL="0">
+            <a:pPr marL="0" indent="0">
               <a:buNone/>
             </a:pPr>
             <a:r>
@@ -2070,6 +1978,13 @@
             <a:prstDash val="solid"/>
           </a:ln>
         </p:spPr>
+        <p:txBody>
+          <a:bodyPr/>
+          <a:lstStyle/>
+          <a:p>
+            <a:endParaRPr lang="en-US"/>
+          </a:p>
+        </p:txBody>
       </p:sp>
       <p:sp>
         <p:nvSpPr>
@@ -2092,7 +2007,7 @@
           <a:bodyPr wrap="square" lIns="0" tIns="0" rIns="0" bIns="0" rtlCol="0" anchor="ctr"/>
           <a:lstStyle/>
           <a:p>
-            <a:pPr indent="0" marL="0">
+            <a:pPr marL="0" indent="0">
               <a:buNone/>
             </a:pPr>
             <a:r>
@@ -2131,7 +2046,7 @@
           <a:bodyPr wrap="square" lIns="0" tIns="0" rIns="0" bIns="0" rtlCol="0" anchor="ctr"/>
           <a:lstStyle/>
           <a:p>
-            <a:pPr indent="0" marL="0">
+            <a:pPr marL="0" indent="0">
               <a:buNone/>
             </a:pPr>
             <a:r>
@@ -2170,7 +2085,7 @@
           <a:bodyPr wrap="square" lIns="0" tIns="0" rIns="0" bIns="0" rtlCol="0" anchor="ctr"/>
           <a:lstStyle/>
           <a:p>
-            <a:pPr indent="0" marL="0">
+            <a:pPr marL="0" indent="0">
               <a:buNone/>
             </a:pPr>
             <a:r>
@@ -2209,7 +2124,7 @@
           <a:bodyPr wrap="square" lIns="0" tIns="0" rIns="0" bIns="0" rtlCol="0" anchor="ctr"/>
           <a:lstStyle/>
           <a:p>
-            <a:pPr indent="0" marL="0">
+            <a:pPr marL="0" indent="0">
               <a:buNone/>
             </a:pPr>
             <a:r>
@@ -2251,6 +2166,13 @@
             <a:prstDash val="solid"/>
           </a:ln>
         </p:spPr>
+        <p:txBody>
+          <a:bodyPr/>
+          <a:lstStyle/>
+          <a:p>
+            <a:endParaRPr lang="en-US"/>
+          </a:p>
+        </p:txBody>
       </p:sp>
       <p:sp>
         <p:nvSpPr>
@@ -2273,7 +2195,7 @@
           <a:bodyPr wrap="square" lIns="0" tIns="0" rIns="0" bIns="0" rtlCol="0" anchor="ctr"/>
           <a:lstStyle/>
           <a:p>
-            <a:pPr indent="0" marL="0">
+            <a:pPr marL="0" indent="0">
               <a:buNone/>
             </a:pPr>
             <a:r>
@@ -2312,7 +2234,7 @@
           <a:bodyPr wrap="square" lIns="0" tIns="0" rIns="0" bIns="0" rtlCol="0" anchor="ctr"/>
           <a:lstStyle/>
           <a:p>
-            <a:pPr indent="0" marL="0">
+            <a:pPr marL="0" indent="0">
               <a:buNone/>
             </a:pPr>
             <a:r>
@@ -2351,7 +2273,7 @@
           <a:bodyPr wrap="square" lIns="0" tIns="0" rIns="0" bIns="0" rtlCol="0" anchor="ctr"/>
           <a:lstStyle/>
           <a:p>
-            <a:pPr indent="0" marL="0">
+            <a:pPr marL="0" indent="0">
               <a:buNone/>
             </a:pPr>
             <a:r>
@@ -2390,7 +2312,7 @@
           <a:bodyPr wrap="square" lIns="0" tIns="0" rIns="0" bIns="0" rtlCol="0" anchor="ctr"/>
           <a:lstStyle/>
           <a:p>
-            <a:pPr indent="0" marL="0">
+            <a:pPr marL="0" indent="0">
               <a:buNone/>
             </a:pPr>
             <a:r>
@@ -2432,6 +2354,13 @@
             <a:prstDash val="solid"/>
           </a:ln>
         </p:spPr>
+        <p:txBody>
+          <a:bodyPr/>
+          <a:lstStyle/>
+          <a:p>
+            <a:endParaRPr lang="en-US"/>
+          </a:p>
+        </p:txBody>
       </p:sp>
       <p:sp>
         <p:nvSpPr>
@@ -2454,7 +2383,7 @@
           <a:bodyPr wrap="square" lIns="0" tIns="0" rIns="0" bIns="0" rtlCol="0" anchor="ctr"/>
           <a:lstStyle/>
           <a:p>
-            <a:pPr indent="0" marL="0">
+            <a:pPr marL="0" indent="0">
               <a:buNone/>
             </a:pPr>
             <a:r>
@@ -2488,6 +2417,7 @@
         <a:solidFill>
           <a:srgbClr val="FFFFFF"/>
         </a:solidFill>
+        <a:effectLst/>
       </p:bgPr>
     </p:bg>
     <p:spTree>
@@ -2528,6 +2458,13 @@
             <a:prstDash val="solid"/>
           </a:ln>
         </p:spPr>
+        <p:txBody>
+          <a:bodyPr/>
+          <a:lstStyle/>
+          <a:p>
+            <a:endParaRPr lang="en-US"/>
+          </a:p>
+        </p:txBody>
       </p:sp>
       <p:sp>
         <p:nvSpPr>
@@ -2553,6 +2490,13 @@
             <a:prstDash val="solid"/>
           </a:ln>
         </p:spPr>
+        <p:txBody>
+          <a:bodyPr/>
+          <a:lstStyle/>
+          <a:p>
+            <a:endParaRPr lang="en-US"/>
+          </a:p>
+        </p:txBody>
       </p:sp>
       <p:sp>
         <p:nvSpPr>
@@ -2575,11 +2519,11 @@
           <a:bodyPr wrap="square" lIns="0" tIns="0" rIns="0" bIns="0" rtlCol="0" anchor="ctr"/>
           <a:lstStyle/>
           <a:p>
-            <a:pPr indent="0" marL="0">
-              <a:buNone/>
-            </a:pPr>
-            <a:r>
-              <a:rPr lang="en-US" sz="850" b="1" spc="300" kern="0" dirty="0">
+            <a:pPr marL="0" indent="0">
+              <a:buNone/>
+            </a:pPr>
+            <a:r>
+              <a:rPr lang="en-US" sz="850" b="1" kern="0" spc="300" dirty="0">
                 <a:solidFill>
                   <a:srgbClr val="888888"/>
                 </a:solidFill>
@@ -2614,7 +2558,7 @@
           <a:bodyPr wrap="square" lIns="0" tIns="0" rIns="0" bIns="0" rtlCol="0" anchor="ctr"/>
           <a:lstStyle/>
           <a:p>
-            <a:pPr indent="0" marL="0">
+            <a:pPr marL="0" indent="0">
               <a:buNone/>
             </a:pPr>
             <a:r>
@@ -2631,7 +2575,7 @@
             <a:endParaRPr lang="en-US" sz="3800" dirty="0"/>
           </a:p>
           <a:p>
-            <a:pPr indent="0" marL="0">
+            <a:pPr marL="0" indent="0">
               <a:buNone/>
             </a:pPr>
             <a:r>
@@ -2651,7 +2595,7 @@
       </p:sp>
       <p:sp>
         <p:nvSpPr>
-          <p:cNvPr id="6" name="Shape 4"/>
+          <p:cNvPr id="7" name="Text 5"/>
           <p:cNvSpPr/>
           <p:nvPr/>
         </p:nvSpPr>
@@ -2663,69 +2607,16 @@
           <a:prstGeom prst="rect">
             <a:avLst/>
           </a:prstGeom>
-          <a:solidFill>
-            <a:srgbClr val="F7F7F5"/>
-          </a:solidFill>
-          <a:ln w="9525">
-            <a:solidFill>
-              <a:srgbClr val="E0E0DC"/>
-            </a:solidFill>
-            <a:prstDash val="solid"/>
-          </a:ln>
-        </p:spPr>
-      </p:sp>
-      <p:sp>
-        <p:nvSpPr>
-          <p:cNvPr id="7" name="Text 5"/>
-          <p:cNvSpPr/>
-          <p:nvPr/>
-        </p:nvSpPr>
-        <p:spPr>
-          <a:xfrm>
-            <a:off x="5943600" y="594360"/>
-            <a:ext cx="2926080" cy="3749040"/>
-          </a:xfrm>
-          <a:prstGeom prst="rect">
-            <a:avLst/>
-          </a:prstGeom>
-          <a:noFill/>
-          <a:ln/>
-        </p:spPr>
-        <p:txBody>
-          <a:bodyPr wrap="square" lIns="0" tIns="0" rIns="0" bIns="0" rtlCol="0" anchor="ctr"/>
-          <a:lstStyle/>
-          <a:p>
-            <a:pPr algn="ctr" indent="0" marL="0">
-              <a:buNone/>
-            </a:pPr>
-            <a:r>
-              <a:rPr lang="en-US" sz="900" dirty="0">
-                <a:solidFill>
-                  <a:srgbClr val="888888"/>
-                </a:solidFill>
-                <a:latin typeface="Calibri" pitchFamily="34" charset="0"/>
-                <a:ea typeface="Calibri" pitchFamily="34" charset="-122"/>
-                <a:cs typeface="Calibri" pitchFamily="34" charset="-120"/>
-              </a:rPr>
-              <a:t>App screenshot</a:t>
-            </a:r>
-            <a:endParaRPr lang="en-US" sz="900" dirty="0"/>
-          </a:p>
-          <a:p>
-            <a:pPr algn="ctr" indent="0" marL="0">
-              <a:buNone/>
-            </a:pPr>
-            <a:r>
-              <a:rPr lang="en-US" sz="900" dirty="0">
-                <a:solidFill>
-                  <a:srgbClr val="888888"/>
-                </a:solidFill>
-                <a:latin typeface="Calibri" pitchFamily="34" charset="0"/>
-                <a:ea typeface="Calibri" pitchFamily="34" charset="-122"/>
-                <a:cs typeface="Calibri" pitchFamily="34" charset="-120"/>
-              </a:rPr>
-              <a:t>(fare + route result card)</a:t>
-            </a:r>
+          <a:noFill/>
+          <a:ln/>
+        </p:spPr>
+        <p:txBody>
+          <a:bodyPr wrap="square" lIns="0" tIns="0" rIns="0" bIns="0" rtlCol="0" anchor="ctr"/>
+          <a:lstStyle/>
+          <a:p>
+            <a:pPr marL="0" indent="0" algn="ctr">
+              <a:buNone/>
+            </a:pPr>
             <a:endParaRPr lang="en-US" sz="900" dirty="0"/>
           </a:p>
         </p:txBody>
@@ -2754,6 +2645,13 @@
             <a:prstDash val="solid"/>
           </a:ln>
         </p:spPr>
+        <p:txBody>
+          <a:bodyPr/>
+          <a:lstStyle/>
+          <a:p>
+            <a:endParaRPr lang="en-US"/>
+          </a:p>
+        </p:txBody>
       </p:sp>
       <p:sp>
         <p:nvSpPr>
@@ -2776,7 +2674,7 @@
           <a:bodyPr wrap="square" lIns="0" tIns="0" rIns="0" bIns="0" rtlCol="0" anchor="ctr"/>
           <a:lstStyle/>
           <a:p>
-            <a:pPr indent="0" marL="0">
+            <a:pPr marL="0" indent="0">
               <a:buNone/>
             </a:pPr>
             <a:r>
@@ -2815,11 +2713,11 @@
           <a:bodyPr wrap="square" lIns="0" tIns="0" rIns="0" bIns="0" rtlCol="0" anchor="ctr"/>
           <a:lstStyle/>
           <a:p>
-            <a:pPr indent="0" marL="0">
-              <a:buNone/>
-            </a:pPr>
-            <a:r>
-              <a:rPr lang="en-US" sz="850" spc="200" kern="0" dirty="0">
+            <a:pPr marL="0" indent="0">
+              <a:buNone/>
+            </a:pPr>
+            <a:r>
+              <a:rPr lang="en-US" sz="850" kern="0" spc="200" dirty="0">
                 <a:solidFill>
                   <a:srgbClr val="888888"/>
                 </a:solidFill>
@@ -2854,7 +2752,7 @@
           <a:bodyPr wrap="square" lIns="0" tIns="0" rIns="0" bIns="0" rtlCol="0" anchor="ctr"/>
           <a:lstStyle/>
           <a:p>
-            <a:pPr indent="0" marL="0">
+            <a:pPr marL="0" indent="0">
               <a:buNone/>
             </a:pPr>
             <a:r>
@@ -2896,6 +2794,13 @@
             <a:prstDash val="solid"/>
           </a:ln>
         </p:spPr>
+        <p:txBody>
+          <a:bodyPr/>
+          <a:lstStyle/>
+          <a:p>
+            <a:endParaRPr lang="en-US"/>
+          </a:p>
+        </p:txBody>
       </p:sp>
       <p:sp>
         <p:nvSpPr>
@@ -2918,7 +2823,7 @@
           <a:bodyPr wrap="square" lIns="0" tIns="0" rIns="0" bIns="0" rtlCol="0" anchor="ctr"/>
           <a:lstStyle/>
           <a:p>
-            <a:pPr indent="0" marL="0">
+            <a:pPr marL="0" indent="0">
               <a:buNone/>
             </a:pPr>
             <a:r>
@@ -2957,11 +2862,11 @@
           <a:bodyPr wrap="square" lIns="0" tIns="0" rIns="0" bIns="0" rtlCol="0" anchor="ctr"/>
           <a:lstStyle/>
           <a:p>
-            <a:pPr indent="0" marL="0">
-              <a:buNone/>
-            </a:pPr>
-            <a:r>
-              <a:rPr lang="en-US" sz="850" spc="200" kern="0" dirty="0">
+            <a:pPr marL="0" indent="0">
+              <a:buNone/>
+            </a:pPr>
+            <a:r>
+              <a:rPr lang="en-US" sz="850" kern="0" spc="200" dirty="0">
                 <a:solidFill>
                   <a:srgbClr val="888888"/>
                 </a:solidFill>
@@ -2996,7 +2901,7 @@
           <a:bodyPr wrap="square" lIns="0" tIns="0" rIns="0" bIns="0" rtlCol="0" anchor="ctr"/>
           <a:lstStyle/>
           <a:p>
-            <a:pPr indent="0" marL="0">
+            <a:pPr marL="0" indent="0">
               <a:buNone/>
             </a:pPr>
             <a:r>
@@ -3038,6 +2943,13 @@
             <a:prstDash val="solid"/>
           </a:ln>
         </p:spPr>
+        <p:txBody>
+          <a:bodyPr/>
+          <a:lstStyle/>
+          <a:p>
+            <a:endParaRPr lang="en-US"/>
+          </a:p>
+        </p:txBody>
       </p:sp>
       <p:sp>
         <p:nvSpPr>
@@ -3060,7 +2972,7 @@
           <a:bodyPr wrap="square" lIns="0" tIns="0" rIns="0" bIns="0" rtlCol="0" anchor="ctr"/>
           <a:lstStyle/>
           <a:p>
-            <a:pPr indent="0" marL="0">
+            <a:pPr marL="0" indent="0">
               <a:buNone/>
             </a:pPr>
             <a:r>
@@ -3099,11 +3011,11 @@
           <a:bodyPr wrap="square" lIns="0" tIns="0" rIns="0" bIns="0" rtlCol="0" anchor="ctr"/>
           <a:lstStyle/>
           <a:p>
-            <a:pPr indent="0" marL="0">
-              <a:buNone/>
-            </a:pPr>
-            <a:r>
-              <a:rPr lang="en-US" sz="850" spc="200" kern="0" dirty="0">
+            <a:pPr marL="0" indent="0">
+              <a:buNone/>
+            </a:pPr>
+            <a:r>
+              <a:rPr lang="en-US" sz="850" kern="0" spc="200" dirty="0">
                 <a:solidFill>
                   <a:srgbClr val="888888"/>
                 </a:solidFill>
@@ -3138,7 +3050,7 @@
           <a:bodyPr wrap="square" lIns="0" tIns="0" rIns="0" bIns="0" rtlCol="0" anchor="ctr"/>
           <a:lstStyle/>
           <a:p>
-            <a:pPr indent="0" marL="0">
+            <a:pPr marL="0" indent="0">
               <a:buNone/>
             </a:pPr>
             <a:r>
@@ -3180,6 +3092,13 @@
             <a:prstDash val="solid"/>
           </a:ln>
         </p:spPr>
+        <p:txBody>
+          <a:bodyPr/>
+          <a:lstStyle/>
+          <a:p>
+            <a:endParaRPr lang="en-US"/>
+          </a:p>
+        </p:txBody>
       </p:sp>
       <p:sp>
         <p:nvSpPr>
@@ -3202,7 +3121,7 @@
           <a:bodyPr wrap="square" lIns="0" tIns="0" rIns="0" bIns="0" rtlCol="0" anchor="ctr"/>
           <a:lstStyle/>
           <a:p>
-            <a:pPr indent="0" marL="0">
+            <a:pPr marL="0" indent="0">
               <a:buNone/>
             </a:pPr>
             <a:r>
@@ -3241,11 +3160,11 @@
           <a:bodyPr wrap="square" lIns="0" tIns="0" rIns="0" bIns="0" rtlCol="0" anchor="ctr"/>
           <a:lstStyle/>
           <a:p>
-            <a:pPr indent="0" marL="0">
-              <a:buNone/>
-            </a:pPr>
-            <a:r>
-              <a:rPr lang="en-US" sz="850" spc="200" kern="0" dirty="0">
+            <a:pPr marL="0" indent="0">
+              <a:buNone/>
+            </a:pPr>
+            <a:r>
+              <a:rPr lang="en-US" sz="850" kern="0" spc="200" dirty="0">
                 <a:solidFill>
                   <a:srgbClr val="888888"/>
                 </a:solidFill>
@@ -3280,7 +3199,7 @@
           <a:bodyPr wrap="square" lIns="0" tIns="0" rIns="0" bIns="0" rtlCol="0" anchor="ctr"/>
           <a:lstStyle/>
           <a:p>
-            <a:pPr indent="0" marL="0">
+            <a:pPr marL="0" indent="0">
               <a:buNone/>
             </a:pPr>
             <a:r>
@@ -3322,6 +3241,13 @@
             <a:prstDash val="solid"/>
           </a:ln>
         </p:spPr>
+        <p:txBody>
+          <a:bodyPr/>
+          <a:lstStyle/>
+          <a:p>
+            <a:endParaRPr lang="en-US"/>
+          </a:p>
+        </p:txBody>
       </p:sp>
       <p:sp>
         <p:nvSpPr>
@@ -3344,7 +3270,7 @@
           <a:bodyPr wrap="square" lIns="0" tIns="0" rIns="0" bIns="0" rtlCol="0" anchor="ctr"/>
           <a:lstStyle/>
           <a:p>
-            <a:pPr indent="0" marL="0">
+            <a:pPr marL="0" indent="0">
               <a:buNone/>
             </a:pPr>
             <a:r>
@@ -3383,11 +3309,11 @@
           <a:bodyPr wrap="square" lIns="0" tIns="0" rIns="0" bIns="0" rtlCol="0" anchor="ctr"/>
           <a:lstStyle/>
           <a:p>
-            <a:pPr indent="0" marL="0">
-              <a:buNone/>
-            </a:pPr>
-            <a:r>
-              <a:rPr lang="en-US" sz="850" spc="200" kern="0" dirty="0">
+            <a:pPr marL="0" indent="0">
+              <a:buNone/>
+            </a:pPr>
+            <a:r>
+              <a:rPr lang="en-US" sz="850" kern="0" spc="200" dirty="0">
                 <a:solidFill>
                   <a:srgbClr val="888888"/>
                 </a:solidFill>
@@ -3422,7 +3348,7 @@
           <a:bodyPr wrap="square" lIns="0" tIns="0" rIns="0" bIns="0" rtlCol="0" anchor="ctr"/>
           <a:lstStyle/>
           <a:p>
-            <a:pPr indent="0" marL="0">
+            <a:pPr marL="0" indent="0">
               <a:buNone/>
             </a:pPr>
             <a:r>
@@ -3464,6 +3390,13 @@
             <a:prstDash val="solid"/>
           </a:ln>
         </p:spPr>
+        <p:txBody>
+          <a:bodyPr/>
+          <a:lstStyle/>
+          <a:p>
+            <a:endParaRPr lang="en-US"/>
+          </a:p>
+        </p:txBody>
       </p:sp>
       <p:sp>
         <p:nvSpPr>
@@ -3486,7 +3419,7 @@
           <a:bodyPr wrap="square" lIns="0" tIns="0" rIns="0" bIns="0" rtlCol="0" anchor="ctr"/>
           <a:lstStyle/>
           <a:p>
-            <a:pPr indent="0" marL="0">
+            <a:pPr marL="0" indent="0">
               <a:buNone/>
             </a:pPr>
             <a:r>
@@ -3504,6 +3437,36 @@
           </a:p>
         </p:txBody>
       </p:sp>
+      <p:pic>
+        <p:nvPicPr>
+          <p:cNvPr id="31" name="Picture 30">
+            <a:extLst>
+              <a:ext uri="{FF2B5EF4-FFF2-40B4-BE49-F238E27FC236}">
+                <a16:creationId xmlns:a16="http://schemas.microsoft.com/office/drawing/2014/main" id="{31F4D91F-C681-2EBB-2F80-4ABA51C73D6E}"/>
+              </a:ext>
+            </a:extLst>
+          </p:cNvPr>
+          <p:cNvPicPr>
+            <a:picLocks noChangeAspect="1"/>
+          </p:cNvPicPr>
+          <p:nvPr/>
+        </p:nvPicPr>
+        <p:blipFill>
+          <a:blip r:embed="rId3"/>
+          <a:stretch>
+            <a:fillRect/>
+          </a:stretch>
+        </p:blipFill>
+        <p:spPr>
+          <a:xfrm>
+            <a:off x="6172200" y="559614"/>
+            <a:ext cx="2468880" cy="3864254"/>
+          </a:xfrm>
+          <a:prstGeom prst="rect">
+            <a:avLst/>
+          </a:prstGeom>
+        </p:spPr>
+      </p:pic>
     </p:spTree>
   </p:cSld>
   <p:clrMapOvr>
@@ -3520,6 +3483,7 @@
         <a:solidFill>
           <a:srgbClr val="FFFFFF"/>
         </a:solidFill>
+        <a:effectLst/>
       </p:bgPr>
     </p:bg>
     <p:spTree>
@@ -3560,6 +3524,13 @@
             <a:prstDash val="solid"/>
           </a:ln>
         </p:spPr>
+        <p:txBody>
+          <a:bodyPr/>
+          <a:lstStyle/>
+          <a:p>
+            <a:endParaRPr lang="en-US"/>
+          </a:p>
+        </p:txBody>
       </p:sp>
       <p:sp>
         <p:nvSpPr>
@@ -3585,6 +3556,13 @@
             <a:prstDash val="solid"/>
           </a:ln>
         </p:spPr>
+        <p:txBody>
+          <a:bodyPr/>
+          <a:lstStyle/>
+          <a:p>
+            <a:endParaRPr lang="en-US"/>
+          </a:p>
+        </p:txBody>
       </p:sp>
       <p:sp>
         <p:nvSpPr>
@@ -3607,11 +3585,11 @@
           <a:bodyPr wrap="square" lIns="0" tIns="0" rIns="0" bIns="0" rtlCol="0" anchor="ctr"/>
           <a:lstStyle/>
           <a:p>
-            <a:pPr indent="0" marL="0">
-              <a:buNone/>
-            </a:pPr>
-            <a:r>
-              <a:rPr lang="en-US" sz="850" b="1" spc="300" kern="0" dirty="0">
+            <a:pPr marL="0" indent="0">
+              <a:buNone/>
+            </a:pPr>
+            <a:r>
+              <a:rPr lang="en-US" sz="850" b="1" kern="0" spc="300" dirty="0">
                 <a:solidFill>
                   <a:srgbClr val="888888"/>
                 </a:solidFill>
@@ -3646,7 +3624,7 @@
           <a:bodyPr wrap="square" lIns="0" tIns="0" rIns="0" bIns="0" rtlCol="0" anchor="ctr"/>
           <a:lstStyle/>
           <a:p>
-            <a:pPr indent="0" marL="0">
+            <a:pPr marL="0" indent="0">
               <a:buNone/>
             </a:pPr>
             <a:r>
@@ -3688,6 +3666,13 @@
             <a:prstDash val="solid"/>
           </a:ln>
         </p:spPr>
+        <p:txBody>
+          <a:bodyPr/>
+          <a:lstStyle/>
+          <a:p>
+            <a:endParaRPr lang="en-US"/>
+          </a:p>
+        </p:txBody>
       </p:sp>
       <p:sp>
         <p:nvSpPr>
@@ -3710,7 +3695,7 @@
           <a:bodyPr wrap="square" lIns="0" tIns="0" rIns="0" bIns="0" rtlCol="0" anchor="ctr"/>
           <a:lstStyle/>
           <a:p>
-            <a:pPr indent="0" marL="0">
+            <a:pPr marL="0" indent="0">
               <a:buNone/>
             </a:pPr>
             <a:r>
@@ -3749,7 +3734,7 @@
           <a:bodyPr wrap="square" lIns="0" tIns="0" rIns="0" bIns="0" rtlCol="0" anchor="ctr"/>
           <a:lstStyle/>
           <a:p>
-            <a:pPr indent="0" marL="0">
+            <a:pPr marL="0" indent="0">
               <a:buNone/>
             </a:pPr>
             <a:r>
@@ -3788,7 +3773,7 @@
           <a:bodyPr wrap="square" lIns="0" tIns="0" rIns="0" bIns="0" rtlCol="0" anchor="ctr"/>
           <a:lstStyle/>
           <a:p>
-            <a:pPr indent="0" marL="0">
+            <a:pPr marL="0" indent="0">
               <a:buNone/>
             </a:pPr>
             <a:r>
@@ -3830,6 +3815,13 @@
             <a:prstDash val="solid"/>
           </a:ln>
         </p:spPr>
+        <p:txBody>
+          <a:bodyPr/>
+          <a:lstStyle/>
+          <a:p>
+            <a:endParaRPr lang="en-US"/>
+          </a:p>
+        </p:txBody>
       </p:sp>
       <p:sp>
         <p:nvSpPr>
@@ -3852,7 +3844,7 @@
           <a:bodyPr wrap="square" lIns="0" tIns="0" rIns="0" bIns="0" rtlCol="0" anchor="ctr"/>
           <a:lstStyle/>
           <a:p>
-            <a:pPr indent="0" marL="0">
+            <a:pPr marL="0" indent="0">
               <a:buNone/>
             </a:pPr>
             <a:r>
@@ -3891,7 +3883,7 @@
           <a:bodyPr wrap="square" lIns="0" tIns="0" rIns="0" bIns="0" rtlCol="0" anchor="ctr"/>
           <a:lstStyle/>
           <a:p>
-            <a:pPr indent="0" marL="0">
+            <a:pPr marL="0" indent="0">
               <a:buNone/>
             </a:pPr>
             <a:r>
@@ -3930,7 +3922,7 @@
           <a:bodyPr wrap="square" lIns="0" tIns="0" rIns="0" bIns="0" rtlCol="0" anchor="ctr"/>
           <a:lstStyle/>
           <a:p>
-            <a:pPr indent="0" marL="0">
+            <a:pPr marL="0" indent="0">
               <a:buNone/>
             </a:pPr>
             <a:r>
@@ -3969,7 +3961,7 @@
           <a:bodyPr wrap="square" lIns="0" tIns="0" rIns="0" bIns="0" rtlCol="0" anchor="ctr"/>
           <a:lstStyle/>
           <a:p>
-            <a:pPr indent="0" marL="0">
+            <a:pPr marL="0" indent="0">
               <a:buNone/>
             </a:pPr>
             <a:r>
@@ -4008,7 +4000,7 @@
           <a:bodyPr wrap="square" lIns="0" tIns="0" rIns="0" bIns="0" rtlCol="0" anchor="ctr"/>
           <a:lstStyle/>
           <a:p>
-            <a:pPr indent="0" marL="0">
+            <a:pPr marL="0" indent="0">
               <a:buNone/>
             </a:pPr>
             <a:r>
@@ -4047,7 +4039,7 @@
           <a:bodyPr wrap="square" lIns="0" tIns="0" rIns="0" bIns="0" rtlCol="0" anchor="ctr"/>
           <a:lstStyle/>
           <a:p>
-            <a:pPr indent="0" marL="0">
+            <a:pPr marL="0" indent="0">
               <a:buNone/>
             </a:pPr>
             <a:r>
@@ -4089,6 +4081,13 @@
             <a:prstDash val="solid"/>
           </a:ln>
         </p:spPr>
+        <p:txBody>
+          <a:bodyPr/>
+          <a:lstStyle/>
+          <a:p>
+            <a:endParaRPr lang="en-US"/>
+          </a:p>
+        </p:txBody>
       </p:sp>
       <p:sp>
         <p:nvSpPr>
@@ -4111,7 +4110,7 @@
           <a:bodyPr wrap="square" lIns="0" tIns="0" rIns="0" bIns="0" rtlCol="0" anchor="ctr"/>
           <a:lstStyle/>
           <a:p>
-            <a:pPr indent="0" marL="0">
+            <a:pPr marL="0" indent="0">
               <a:buNone/>
             </a:pPr>
             <a:r>
@@ -4150,7 +4149,7 @@
           <a:bodyPr wrap="square" lIns="0" tIns="0" rIns="0" bIns="0" rtlCol="0" anchor="ctr"/>
           <a:lstStyle/>
           <a:p>
-            <a:pPr indent="0" marL="0">
+            <a:pPr marL="0" indent="0">
               <a:buNone/>
             </a:pPr>
             <a:r>
@@ -4189,7 +4188,7 @@
           <a:bodyPr wrap="square" lIns="0" tIns="0" rIns="0" bIns="0" rtlCol="0" anchor="ctr"/>
           <a:lstStyle/>
           <a:p>
-            <a:pPr indent="0" marL="0">
+            <a:pPr marL="0" indent="0">
               <a:buNone/>
             </a:pPr>
             <a:r>
@@ -4228,7 +4227,7 @@
           <a:bodyPr wrap="square" lIns="0" tIns="0" rIns="0" bIns="0" rtlCol="0" anchor="ctr"/>
           <a:lstStyle/>
           <a:p>
-            <a:pPr indent="0" marL="0">
+            <a:pPr marL="0" indent="0">
               <a:buNone/>
             </a:pPr>
             <a:r>
@@ -4267,7 +4266,7 @@
           <a:bodyPr wrap="square" lIns="0" tIns="0" rIns="0" bIns="0" rtlCol="0" anchor="ctr"/>
           <a:lstStyle/>
           <a:p>
-            <a:pPr indent="0" marL="0">
+            <a:pPr marL="0" indent="0">
               <a:buNone/>
             </a:pPr>
             <a:r>
@@ -4306,7 +4305,7 @@
           <a:bodyPr wrap="square" lIns="0" tIns="0" rIns="0" bIns="0" rtlCol="0" anchor="ctr"/>
           <a:lstStyle/>
           <a:p>
-            <a:pPr indent="0" marL="0">
+            <a:pPr marL="0" indent="0">
               <a:buNone/>
             </a:pPr>
             <a:r>
@@ -4345,7 +4344,7 @@
           <a:bodyPr wrap="square" lIns="0" tIns="0" rIns="0" bIns="0" rtlCol="0" anchor="ctr"/>
           <a:lstStyle/>
           <a:p>
-            <a:pPr indent="0" marL="0">
+            <a:pPr marL="0" indent="0">
               <a:buNone/>
             </a:pPr>
             <a:r>
@@ -4384,7 +4383,7 @@
           <a:bodyPr wrap="square" lIns="0" tIns="0" rIns="0" bIns="0" rtlCol="0" anchor="ctr"/>
           <a:lstStyle/>
           <a:p>
-            <a:pPr indent="0" marL="0">
+            <a:pPr marL="0" indent="0">
               <a:buNone/>
             </a:pPr>
             <a:r>
@@ -4423,7 +4422,7 @@
           <a:bodyPr wrap="square" lIns="0" tIns="0" rIns="0" bIns="0" rtlCol="0" anchor="ctr"/>
           <a:lstStyle/>
           <a:p>
-            <a:pPr indent="0" marL="0">
+            <a:pPr marL="0" indent="0">
               <a:buNone/>
             </a:pPr>
             <a:r>
@@ -4465,6 +4464,13 @@
             <a:prstDash val="solid"/>
           </a:ln>
         </p:spPr>
+        <p:txBody>
+          <a:bodyPr/>
+          <a:lstStyle/>
+          <a:p>
+            <a:endParaRPr lang="en-US"/>
+          </a:p>
+        </p:txBody>
       </p:sp>
       <p:sp>
         <p:nvSpPr>
@@ -4487,7 +4493,7 @@
           <a:bodyPr wrap="square" lIns="0" tIns="0" rIns="0" bIns="0" rtlCol="0" anchor="ctr"/>
           <a:lstStyle/>
           <a:p>
-            <a:pPr indent="0" marL="0">
+            <a:pPr marL="0" indent="0">
               <a:buNone/>
             </a:pPr>
             <a:r>
@@ -4521,6 +4527,7 @@
         <a:solidFill>
           <a:srgbClr val="FFFFFF"/>
         </a:solidFill>
+        <a:effectLst/>
       </p:bgPr>
     </p:bg>
     <p:spTree>
@@ -4561,6 +4568,13 @@
             <a:prstDash val="solid"/>
           </a:ln>
         </p:spPr>
+        <p:txBody>
+          <a:bodyPr/>
+          <a:lstStyle/>
+          <a:p>
+            <a:endParaRPr lang="en-US"/>
+          </a:p>
+        </p:txBody>
       </p:sp>
       <p:sp>
         <p:nvSpPr>
@@ -4586,6 +4600,13 @@
             <a:prstDash val="solid"/>
           </a:ln>
         </p:spPr>
+        <p:txBody>
+          <a:bodyPr/>
+          <a:lstStyle/>
+          <a:p>
+            <a:endParaRPr lang="en-US"/>
+          </a:p>
+        </p:txBody>
       </p:sp>
       <p:sp>
         <p:nvSpPr>
@@ -4608,11 +4629,11 @@
           <a:bodyPr wrap="square" lIns="0" tIns="0" rIns="0" bIns="0" rtlCol="0" anchor="ctr"/>
           <a:lstStyle/>
           <a:p>
-            <a:pPr indent="0" marL="0">
-              <a:buNone/>
-            </a:pPr>
-            <a:r>
-              <a:rPr lang="en-US" sz="850" b="1" spc="300" kern="0" dirty="0">
+            <a:pPr marL="0" indent="0">
+              <a:buNone/>
+            </a:pPr>
+            <a:r>
+              <a:rPr lang="en-US" sz="850" b="1" kern="0" spc="300" dirty="0">
                 <a:solidFill>
                   <a:srgbClr val="888888"/>
                 </a:solidFill>
@@ -4647,7 +4668,7 @@
           <a:bodyPr wrap="square" lIns="0" tIns="0" rIns="0" bIns="0" rtlCol="0" anchor="ctr"/>
           <a:lstStyle/>
           <a:p>
-            <a:pPr indent="0" marL="0">
+            <a:pPr marL="0" indent="0">
               <a:buNone/>
             </a:pPr>
             <a:r>
@@ -4664,7 +4685,7 @@
             <a:endParaRPr lang="en-US" sz="3800" dirty="0"/>
           </a:p>
           <a:p>
-            <a:pPr indent="0" marL="0">
+            <a:pPr marL="0" indent="0">
               <a:buNone/>
             </a:pPr>
             <a:r>
@@ -4706,6 +4727,13 @@
             <a:prstDash val="solid"/>
           </a:ln>
         </p:spPr>
+        <p:txBody>
+          <a:bodyPr/>
+          <a:lstStyle/>
+          <a:p>
+            <a:endParaRPr lang="en-US"/>
+          </a:p>
+        </p:txBody>
       </p:sp>
       <p:sp>
         <p:nvSpPr>
@@ -4728,7 +4756,7 @@
           <a:bodyPr wrap="square" lIns="0" tIns="0" rIns="0" bIns="0" rtlCol="0" anchor="ctr"/>
           <a:lstStyle/>
           <a:p>
-            <a:pPr indent="0" marL="0">
+            <a:pPr marL="0" indent="0">
               <a:buNone/>
             </a:pPr>
             <a:r>
@@ -4767,7 +4795,7 @@
           <a:bodyPr wrap="square" lIns="0" tIns="0" rIns="0" bIns="0" rtlCol="0" anchor="ctr"/>
           <a:lstStyle/>
           <a:p>
-            <a:pPr indent="0" marL="0">
+            <a:pPr marL="0" indent="0">
               <a:buNone/>
             </a:pPr>
             <a:r>
@@ -4806,7 +4834,7 @@
           <a:bodyPr wrap="square" lIns="0" tIns="0" rIns="0" bIns="0" rtlCol="0" anchor="ctr"/>
           <a:lstStyle/>
           <a:p>
-            <a:pPr indent="0" marL="0">
+            <a:pPr marL="0" indent="0">
               <a:buNone/>
             </a:pPr>
             <a:r>
@@ -4848,6 +4876,13 @@
             <a:prstDash val="solid"/>
           </a:ln>
         </p:spPr>
+        <p:txBody>
+          <a:bodyPr/>
+          <a:lstStyle/>
+          <a:p>
+            <a:endParaRPr lang="en-US"/>
+          </a:p>
+        </p:txBody>
       </p:sp>
       <p:sp>
         <p:nvSpPr>
@@ -4870,7 +4905,7 @@
           <a:bodyPr wrap="square" lIns="0" tIns="0" rIns="0" bIns="0" rtlCol="0" anchor="ctr"/>
           <a:lstStyle/>
           <a:p>
-            <a:pPr indent="0" marL="0">
+            <a:pPr marL="0" indent="0">
               <a:buNone/>
             </a:pPr>
             <a:r>
@@ -4909,7 +4944,7 @@
           <a:bodyPr wrap="square" lIns="0" tIns="0" rIns="0" bIns="0" rtlCol="0" anchor="ctr"/>
           <a:lstStyle/>
           <a:p>
-            <a:pPr indent="0" marL="0">
+            <a:pPr marL="0" indent="0">
               <a:buNone/>
             </a:pPr>
             <a:r>
@@ -4948,7 +4983,7 @@
           <a:bodyPr wrap="square" lIns="0" tIns="0" rIns="0" bIns="0" rtlCol="0" anchor="ctr"/>
           <a:lstStyle/>
           <a:p>
-            <a:pPr indent="0" marL="0">
+            <a:pPr marL="0" indent="0">
               <a:buNone/>
             </a:pPr>
             <a:r>
@@ -4990,6 +5025,13 @@
             <a:prstDash val="solid"/>
           </a:ln>
         </p:spPr>
+        <p:txBody>
+          <a:bodyPr/>
+          <a:lstStyle/>
+          <a:p>
+            <a:endParaRPr lang="en-US"/>
+          </a:p>
+        </p:txBody>
       </p:sp>
       <p:sp>
         <p:nvSpPr>
@@ -5012,7 +5054,7 @@
           <a:bodyPr wrap="square" lIns="0" tIns="0" rIns="0" bIns="0" rtlCol="0" anchor="ctr"/>
           <a:lstStyle/>
           <a:p>
-            <a:pPr indent="0" marL="0">
+            <a:pPr marL="0" indent="0">
               <a:buNone/>
             </a:pPr>
             <a:r>
@@ -5051,7 +5093,7 @@
           <a:bodyPr wrap="square" lIns="0" tIns="0" rIns="0" bIns="0" rtlCol="0" anchor="ctr"/>
           <a:lstStyle/>
           <a:p>
-            <a:pPr indent="0" marL="0">
+            <a:pPr marL="0" indent="0">
               <a:buNone/>
             </a:pPr>
             <a:r>
@@ -5090,7 +5132,7 @@
           <a:bodyPr wrap="square" lIns="0" tIns="0" rIns="0" bIns="0" rtlCol="0" anchor="ctr"/>
           <a:lstStyle/>
           <a:p>
-            <a:pPr indent="0" marL="0">
+            <a:pPr marL="0" indent="0">
               <a:buNone/>
             </a:pPr>
             <a:r>
@@ -5132,6 +5174,13 @@
             <a:prstDash val="solid"/>
           </a:ln>
         </p:spPr>
+        <p:txBody>
+          <a:bodyPr/>
+          <a:lstStyle/>
+          <a:p>
+            <a:endParaRPr lang="en-US"/>
+          </a:p>
+        </p:txBody>
       </p:sp>
       <p:sp>
         <p:nvSpPr>
@@ -5154,7 +5203,7 @@
           <a:bodyPr wrap="square" lIns="0" tIns="0" rIns="0" bIns="0" rtlCol="0" anchor="ctr"/>
           <a:lstStyle/>
           <a:p>
-            <a:pPr indent="0" marL="0">
+            <a:pPr marL="0" indent="0">
               <a:buNone/>
             </a:pPr>
             <a:r>
@@ -5193,7 +5242,7 @@
           <a:bodyPr wrap="square" lIns="0" tIns="0" rIns="0" bIns="0" rtlCol="0" anchor="ctr"/>
           <a:lstStyle/>
           <a:p>
-            <a:pPr indent="0" marL="0">
+            <a:pPr marL="0" indent="0">
               <a:buNone/>
             </a:pPr>
             <a:r>
@@ -5232,7 +5281,7 @@
           <a:bodyPr wrap="square" lIns="0" tIns="0" rIns="0" bIns="0" rtlCol="0" anchor="ctr"/>
           <a:lstStyle/>
           <a:p>
-            <a:pPr indent="0" marL="0">
+            <a:pPr marL="0" indent="0">
               <a:buNone/>
             </a:pPr>
             <a:r>
@@ -5252,7 +5301,7 @@
       </p:sp>
       <p:sp>
         <p:nvSpPr>
-          <p:cNvPr id="22" name="Shape 20"/>
+          <p:cNvPr id="23" name="Text 21"/>
           <p:cNvSpPr/>
           <p:nvPr/>
         </p:nvSpPr>
@@ -5264,56 +5313,51 @@
           <a:prstGeom prst="rect">
             <a:avLst/>
           </a:prstGeom>
-          <a:solidFill>
-            <a:srgbClr val="F7F7F5"/>
-          </a:solidFill>
-          <a:ln w="9525">
-            <a:solidFill>
-              <a:srgbClr val="E0E0DC"/>
-            </a:solidFill>
-            <a:prstDash val="solid"/>
-          </a:ln>
-        </p:spPr>
-      </p:sp>
-      <p:sp>
-        <p:nvSpPr>
-          <p:cNvPr id="23" name="Text 21"/>
-          <p:cNvSpPr/>
-          <p:nvPr/>
-        </p:nvSpPr>
-        <p:spPr>
-          <a:xfrm>
-            <a:off x="502920" y="4224528"/>
-            <a:ext cx="8138160" cy="685800"/>
-          </a:xfrm>
-          <a:prstGeom prst="rect">
-            <a:avLst/>
-          </a:prstGeom>
-          <a:noFill/>
-          <a:ln/>
-        </p:spPr>
-        <p:txBody>
-          <a:bodyPr wrap="square" lIns="0" tIns="0" rIns="0" bIns="0" rtlCol="0" anchor="ctr"/>
-          <a:lstStyle/>
-          <a:p>
-            <a:pPr algn="ctr" indent="0" marL="0">
-              <a:buNone/>
-            </a:pPr>
-            <a:r>
-              <a:rPr lang="en-US" sz="900" dirty="0">
-                <a:solidFill>
-                  <a:srgbClr val="888888"/>
-                </a:solidFill>
-                <a:latin typeface="Calibri" pitchFamily="34" charset="0"/>
-                <a:ea typeface="Calibri" pitchFamily="34" charset="-122"/>
-                <a:cs typeface="Calibri" pitchFamily="34" charset="-120"/>
-              </a:rPr>
-              <a:t>App screenshot — place a wide route result / journey panel screenshot here</a:t>
-            </a:r>
+          <a:noFill/>
+          <a:ln/>
+        </p:spPr>
+        <p:txBody>
+          <a:bodyPr wrap="square" lIns="0" tIns="0" rIns="0" bIns="0" rtlCol="0" anchor="ctr"/>
+          <a:lstStyle/>
+          <a:p>
+            <a:pPr marL="0" indent="0" algn="ctr">
+              <a:buNone/>
+            </a:pPr>
             <a:endParaRPr lang="en-US" sz="900" dirty="0"/>
           </a:p>
         </p:txBody>
       </p:sp>
+      <p:pic>
+        <p:nvPicPr>
+          <p:cNvPr id="29" name="Picture 28">
+            <a:extLst>
+              <a:ext uri="{FF2B5EF4-FFF2-40B4-BE49-F238E27FC236}">
+                <a16:creationId xmlns:a16="http://schemas.microsoft.com/office/drawing/2014/main" id="{F07223B1-B8B1-3B51-7391-AB221DA59C48}"/>
+              </a:ext>
+            </a:extLst>
+          </p:cNvPr>
+          <p:cNvPicPr>
+            <a:picLocks noChangeAspect="1"/>
+          </p:cNvPicPr>
+          <p:nvPr/>
+        </p:nvPicPr>
+        <p:blipFill>
+          <a:blip r:embed="rId3"/>
+          <a:srcRect t="16022" b="24569"/>
+          <a:stretch>
+            <a:fillRect/>
+          </a:stretch>
+        </p:blipFill>
+        <p:spPr>
+          <a:xfrm>
+            <a:off x="331928" y="4167835"/>
+            <a:ext cx="8309152" cy="762610"/>
+          </a:xfrm>
+          <a:prstGeom prst="rect">
+            <a:avLst/>
+          </a:prstGeom>
+        </p:spPr>
+      </p:pic>
     </p:spTree>
   </p:cSld>
   <p:clrMapOvr>
@@ -5330,6 +5374,7 @@
         <a:solidFill>
           <a:srgbClr val="FFFFFF"/>
         </a:solidFill>
+        <a:effectLst/>
       </p:bgPr>
     </p:bg>
     <p:spTree>
@@ -5370,6 +5415,13 @@
             <a:prstDash val="solid"/>
           </a:ln>
         </p:spPr>
+        <p:txBody>
+          <a:bodyPr/>
+          <a:lstStyle/>
+          <a:p>
+            <a:endParaRPr lang="en-US"/>
+          </a:p>
+        </p:txBody>
       </p:sp>
       <p:sp>
         <p:nvSpPr>
@@ -5395,6 +5447,13 @@
             <a:prstDash val="solid"/>
           </a:ln>
         </p:spPr>
+        <p:txBody>
+          <a:bodyPr/>
+          <a:lstStyle/>
+          <a:p>
+            <a:endParaRPr lang="en-US"/>
+          </a:p>
+        </p:txBody>
       </p:sp>
       <p:sp>
         <p:nvSpPr>
@@ -5417,11 +5476,11 @@
           <a:bodyPr wrap="square" lIns="0" tIns="0" rIns="0" bIns="0" rtlCol="0" anchor="ctr"/>
           <a:lstStyle/>
           <a:p>
-            <a:pPr indent="0" marL="0">
-              <a:buNone/>
-            </a:pPr>
-            <a:r>
-              <a:rPr lang="en-US" sz="850" b="1" spc="300" kern="0" dirty="0">
+            <a:pPr marL="0" indent="0">
+              <a:buNone/>
+            </a:pPr>
+            <a:r>
+              <a:rPr lang="en-US" sz="850" b="1" kern="0" spc="300" dirty="0">
                 <a:solidFill>
                   <a:srgbClr val="888888"/>
                 </a:solidFill>
@@ -5456,7 +5515,7 @@
           <a:bodyPr wrap="square" lIns="0" tIns="0" rIns="0" bIns="0" rtlCol="0" anchor="ctr"/>
           <a:lstStyle/>
           <a:p>
-            <a:pPr indent="0" marL="0">
+            <a:pPr marL="0" indent="0">
               <a:buNone/>
             </a:pPr>
             <a:r>
@@ -5495,7 +5554,7 @@
           <a:bodyPr wrap="square" lIns="0" tIns="0" rIns="0" bIns="0" rtlCol="0" anchor="ctr"/>
           <a:lstStyle/>
           <a:p>
-            <a:pPr indent="0" marL="0">
+            <a:pPr marL="0" indent="0">
               <a:buNone/>
             </a:pPr>
             <a:r>
@@ -5537,6 +5596,13 @@
             <a:prstDash val="solid"/>
           </a:ln>
         </p:spPr>
+        <p:txBody>
+          <a:bodyPr/>
+          <a:lstStyle/>
+          <a:p>
+            <a:endParaRPr lang="en-US"/>
+          </a:p>
+        </p:txBody>
       </p:sp>
       <p:sp>
         <p:nvSpPr>
@@ -5562,6 +5628,13 @@
             <a:prstDash val="solid"/>
           </a:ln>
         </p:spPr>
+        <p:txBody>
+          <a:bodyPr/>
+          <a:lstStyle/>
+          <a:p>
+            <a:endParaRPr lang="en-US"/>
+          </a:p>
+        </p:txBody>
       </p:sp>
       <p:sp>
         <p:nvSpPr>
@@ -5584,7 +5657,7 @@
           <a:bodyPr wrap="square" lIns="0" tIns="0" rIns="0" bIns="0" rtlCol="0" anchor="ctr"/>
           <a:lstStyle/>
           <a:p>
-            <a:pPr algn="ctr" indent="0" marL="0">
+            <a:pPr marL="0" indent="0" algn="ctr">
               <a:buNone/>
             </a:pPr>
             <a:r>
@@ -5626,6 +5699,13 @@
             <a:prstDash val="solid"/>
           </a:ln>
         </p:spPr>
+        <p:txBody>
+          <a:bodyPr/>
+          <a:lstStyle/>
+          <a:p>
+            <a:endParaRPr lang="en-US"/>
+          </a:p>
+        </p:txBody>
       </p:sp>
       <p:sp>
         <p:nvSpPr>
@@ -5648,7 +5728,7 @@
           <a:bodyPr wrap="square" lIns="0" tIns="0" rIns="0" bIns="0" rtlCol="0" anchor="ctr"/>
           <a:lstStyle/>
           <a:p>
-            <a:pPr algn="ctr" indent="0" marL="0">
+            <a:pPr marL="0" indent="0" algn="ctr">
               <a:buNone/>
             </a:pPr>
             <a:r>
@@ -5690,6 +5770,13 @@
             <a:prstDash val="solid"/>
           </a:ln>
         </p:spPr>
+        <p:txBody>
+          <a:bodyPr/>
+          <a:lstStyle/>
+          <a:p>
+            <a:endParaRPr lang="en-US"/>
+          </a:p>
+        </p:txBody>
       </p:sp>
       <p:sp>
         <p:nvSpPr>
@@ -5712,7 +5799,7 @@
           <a:bodyPr wrap="square" lIns="0" tIns="0" rIns="0" bIns="0" rtlCol="0" anchor="ctr"/>
           <a:lstStyle/>
           <a:p>
-            <a:pPr algn="ctr" indent="0" marL="0">
+            <a:pPr marL="0" indent="0" algn="ctr">
               <a:buNone/>
             </a:pPr>
             <a:r>
@@ -5754,6 +5841,13 @@
             <a:prstDash val="solid"/>
           </a:ln>
         </p:spPr>
+        <p:txBody>
+          <a:bodyPr/>
+          <a:lstStyle/>
+          <a:p>
+            <a:endParaRPr lang="en-US"/>
+          </a:p>
+        </p:txBody>
       </p:sp>
       <p:sp>
         <p:nvSpPr>
@@ -5776,7 +5870,7 @@
           <a:bodyPr wrap="square" lIns="0" tIns="0" rIns="0" bIns="0" rtlCol="0" anchor="ctr"/>
           <a:lstStyle/>
           <a:p>
-            <a:pPr algn="ctr" indent="0" marL="0">
+            <a:pPr marL="0" indent="0" algn="ctr">
               <a:buNone/>
             </a:pPr>
             <a:r>
@@ -5818,6 +5912,13 @@
             <a:prstDash val="solid"/>
           </a:ln>
         </p:spPr>
+        <p:txBody>
+          <a:bodyPr/>
+          <a:lstStyle/>
+          <a:p>
+            <a:endParaRPr lang="en-US"/>
+          </a:p>
+        </p:txBody>
       </p:sp>
       <p:sp>
         <p:nvSpPr>
@@ -5840,7 +5941,7 @@
           <a:bodyPr wrap="square" lIns="0" tIns="0" rIns="0" bIns="0" rtlCol="0" anchor="ctr"/>
           <a:lstStyle/>
           <a:p>
-            <a:pPr algn="ctr" indent="0" marL="0">
+            <a:pPr marL="0" indent="0" algn="ctr">
               <a:buNone/>
             </a:pPr>
             <a:r>
@@ -5879,7 +5980,7 @@
           <a:bodyPr wrap="square" lIns="0" tIns="0" rIns="0" bIns="0" rtlCol="0" anchor="ctr"/>
           <a:lstStyle/>
           <a:p>
-            <a:pPr indent="0" marL="0">
+            <a:pPr marL="0" indent="0">
               <a:buNone/>
             </a:pPr>
             <a:r>
@@ -5921,6 +6022,13 @@
             <a:prstDash val="solid"/>
           </a:ln>
         </p:spPr>
+        <p:txBody>
+          <a:bodyPr/>
+          <a:lstStyle/>
+          <a:p>
+            <a:endParaRPr lang="en-US"/>
+          </a:p>
+        </p:txBody>
       </p:sp>
       <p:sp>
         <p:nvSpPr>
@@ -5943,7 +6051,7 @@
           <a:bodyPr wrap="square" lIns="0" tIns="0" rIns="0" bIns="0" rtlCol="0" anchor="ctr"/>
           <a:lstStyle/>
           <a:p>
-            <a:pPr indent="0" marL="0">
+            <a:pPr marL="0" indent="0">
               <a:buNone/>
             </a:pPr>
             <a:r>
@@ -5955,7 +6063,7 @@
                 <a:ea typeface="Calibri" pitchFamily="34" charset="-122"/>
                 <a:cs typeface="Calibri" pitchFamily="34" charset="-120"/>
               </a:rPr>
-              <a:t>Zenith Kandel  ·  Team Spark</a:t>
+              <a:t>  Team Spark</a:t>
             </a:r>
             <a:endParaRPr lang="en-US" sz="1100" dirty="0"/>
           </a:p>
@@ -6262,4 +6370,319 @@
     </a:ext>
   </a:extLst>
 </a:theme>
+</file>
+
+<file path=ppt/theme/theme2.xml><?xml version="1.0" encoding="utf-8"?>
+<a:theme xmlns:a="http://schemas.openxmlformats.org/drawingml/2006/main" name="Office Theme">
+  <a:themeElements>
+    <a:clrScheme name="Office">
+      <a:dk1>
+        <a:sysClr val="windowText" lastClr="000000"/>
+      </a:dk1>
+      <a:lt1>
+        <a:sysClr val="window" lastClr="FFFFFF"/>
+      </a:lt1>
+      <a:dk2>
+        <a:srgbClr val="0E2841"/>
+      </a:dk2>
+      <a:lt2>
+        <a:srgbClr val="E8E8E8"/>
+      </a:lt2>
+      <a:accent1>
+        <a:srgbClr val="156082"/>
+      </a:accent1>
+      <a:accent2>
+        <a:srgbClr val="E97132"/>
+      </a:accent2>
+      <a:accent3>
+        <a:srgbClr val="196B24"/>
+      </a:accent3>
+      <a:accent4>
+        <a:srgbClr val="0F9ED5"/>
+      </a:accent4>
+      <a:accent5>
+        <a:srgbClr val="A02B93"/>
+      </a:accent5>
+      <a:accent6>
+        <a:srgbClr val="4EA72E"/>
+      </a:accent6>
+      <a:hlink>
+        <a:srgbClr val="467886"/>
+      </a:hlink>
+      <a:folHlink>
+        <a:srgbClr val="96607D"/>
+      </a:folHlink>
+    </a:clrScheme>
+    <a:fontScheme name="Office">
+      <a:majorFont>
+        <a:latin typeface="Aptos Display" panose="02110004020202020204"/>
+        <a:ea typeface=""/>
+        <a:cs typeface=""/>
+        <a:font script="Jpan" typeface="游ゴシック Light"/>
+        <a:font script="Hang" typeface="맑은 고딕"/>
+        <a:font script="Hans" typeface="等线 Light"/>
+        <a:font script="Hant" typeface="新細明體"/>
+        <a:font script="Arab" typeface="Times New Roman"/>
+        <a:font script="Hebr" typeface="Times New Roman"/>
+        <a:font script="Thai" typeface="Angsana New"/>
+        <a:font script="Ethi" typeface="Nyala"/>
+        <a:font script="Beng" typeface="Vrinda"/>
+        <a:font script="Gujr" typeface="Shruti"/>
+        <a:font script="Khmr" typeface="MoolBoran"/>
+        <a:font script="Knda" typeface="Tunga"/>
+        <a:font script="Guru" typeface="Raavi"/>
+        <a:font script="Cans" typeface="Euphemia"/>
+        <a:font script="Cher" typeface="Plantagenet Cherokee"/>
+        <a:font script="Yiii" typeface="Microsoft Yi Baiti"/>
+        <a:font script="Tibt" typeface="Microsoft Himalaya"/>
+        <a:font script="Thaa" typeface="MV Boli"/>
+        <a:font script="Deva" typeface="Mangal"/>
+        <a:font script="Telu" typeface="Gautami"/>
+        <a:font script="Taml" typeface="Latha"/>
+        <a:font script="Syrc" typeface="Estrangelo Edessa"/>
+        <a:font script="Orya" typeface="Kalinga"/>
+        <a:font script="Mlym" typeface="Kartika"/>
+        <a:font script="Laoo" typeface="DokChampa"/>
+        <a:font script="Sinh" typeface="Iskoola Pota"/>
+        <a:font script="Mong" typeface="Mongolian Baiti"/>
+        <a:font script="Viet" typeface="Times New Roman"/>
+        <a:font script="Uigh" typeface="Microsoft Uighur"/>
+        <a:font script="Geor" typeface="Sylfaen"/>
+        <a:font script="Armn" typeface="Arial"/>
+        <a:font script="Bugi" typeface="Leelawadee UI"/>
+        <a:font script="Bopo" typeface="Microsoft JhengHei"/>
+        <a:font script="Java" typeface="Javanese Text"/>
+        <a:font script="Lisu" typeface="Segoe UI"/>
+        <a:font script="Mymr" typeface="Myanmar Text"/>
+        <a:font script="Nkoo" typeface="Ebrima"/>
+        <a:font script="Olck" typeface="Nirmala UI"/>
+        <a:font script="Osma" typeface="Ebrima"/>
+        <a:font script="Phag" typeface="Phagspa"/>
+        <a:font script="Syrn" typeface="Estrangelo Edessa"/>
+        <a:font script="Syrj" typeface="Estrangelo Edessa"/>
+        <a:font script="Syre" typeface="Estrangelo Edessa"/>
+        <a:font script="Sora" typeface="Nirmala UI"/>
+        <a:font script="Tale" typeface="Microsoft Tai Le"/>
+        <a:font script="Talu" typeface="Microsoft New Tai Lue"/>
+        <a:font script="Tfng" typeface="Ebrima"/>
+      </a:majorFont>
+      <a:minorFont>
+        <a:latin typeface="Aptos" panose="02110004020202020204"/>
+        <a:ea typeface=""/>
+        <a:cs typeface=""/>
+        <a:font script="Jpan" typeface="游ゴシック"/>
+        <a:font script="Hang" typeface="맑은 고딕"/>
+        <a:font script="Hans" typeface="等线"/>
+        <a:font script="Hant" typeface="新細明體"/>
+        <a:font script="Arab" typeface="Arial"/>
+        <a:font script="Hebr" typeface="Arial"/>
+        <a:font script="Thai" typeface="Cordia New"/>
+        <a:font script="Ethi" typeface="Nyala"/>
+        <a:font script="Beng" typeface="Vrinda"/>
+        <a:font script="Gujr" typeface="Shruti"/>
+        <a:font script="Khmr" typeface="DaunPenh"/>
+        <a:font script="Knda" typeface="Tunga"/>
+        <a:font script="Guru" typeface="Raavi"/>
+        <a:font script="Cans" typeface="Euphemia"/>
+        <a:font script="Cher" typeface="Plantagenet Cherokee"/>
+        <a:font script="Yiii" typeface="Microsoft Yi Baiti"/>
+        <a:font script="Tibt" typeface="Microsoft Himalaya"/>
+        <a:font script="Thaa" typeface="MV Boli"/>
+        <a:font script="Deva" typeface="Mangal"/>
+        <a:font script="Telu" typeface="Gautami"/>
+        <a:font script="Taml" typeface="Latha"/>
+        <a:font script="Syrc" typeface="Estrangelo Edessa"/>
+        <a:font script="Orya" typeface="Kalinga"/>
+        <a:font script="Mlym" typeface="Kartika"/>
+        <a:font script="Laoo" typeface="DokChampa"/>
+        <a:font script="Sinh" typeface="Iskoola Pota"/>
+        <a:font script="Mong" typeface="Mongolian Baiti"/>
+        <a:font script="Viet" typeface="Arial"/>
+        <a:font script="Uigh" typeface="Microsoft Uighur"/>
+        <a:font script="Geor" typeface="Sylfaen"/>
+        <a:font script="Armn" typeface="Arial"/>
+        <a:font script="Bugi" typeface="Leelawadee UI"/>
+        <a:font script="Bopo" typeface="Microsoft JhengHei"/>
+        <a:font script="Java" typeface="Javanese Text"/>
+        <a:font script="Lisu" typeface="Segoe UI"/>
+        <a:font script="Mymr" typeface="Myanmar Text"/>
+        <a:font script="Nkoo" typeface="Ebrima"/>
+        <a:font script="Olck" typeface="Nirmala UI"/>
+        <a:font script="Osma" typeface="Ebrima"/>
+        <a:font script="Phag" typeface="Phagspa"/>
+        <a:font script="Syrn" typeface="Estrangelo Edessa"/>
+        <a:font script="Syrj" typeface="Estrangelo Edessa"/>
+        <a:font script="Syre" typeface="Estrangelo Edessa"/>
+        <a:font script="Sora" typeface="Nirmala UI"/>
+        <a:font script="Tale" typeface="Microsoft Tai Le"/>
+        <a:font script="Talu" typeface="Microsoft New Tai Lue"/>
+        <a:font script="Tfng" typeface="Ebrima"/>
+      </a:minorFont>
+    </a:fontScheme>
+    <a:fmtScheme name="Office">
+      <a:fillStyleLst>
+        <a:solidFill>
+          <a:schemeClr val="phClr"/>
+        </a:solidFill>
+        <a:gradFill rotWithShape="1">
+          <a:gsLst>
+            <a:gs pos="0">
+              <a:schemeClr val="phClr">
+                <a:lumMod val="110000"/>
+                <a:satMod val="105000"/>
+                <a:tint val="67000"/>
+              </a:schemeClr>
+            </a:gs>
+            <a:gs pos="50000">
+              <a:schemeClr val="phClr">
+                <a:lumMod val="105000"/>
+                <a:satMod val="103000"/>
+                <a:tint val="73000"/>
+              </a:schemeClr>
+            </a:gs>
+            <a:gs pos="100000">
+              <a:schemeClr val="phClr">
+                <a:lumMod val="105000"/>
+                <a:satMod val="109000"/>
+                <a:tint val="81000"/>
+              </a:schemeClr>
+            </a:gs>
+          </a:gsLst>
+          <a:lin ang="5400000" scaled="0"/>
+        </a:gradFill>
+        <a:gradFill rotWithShape="1">
+          <a:gsLst>
+            <a:gs pos="0">
+              <a:schemeClr val="phClr">
+                <a:satMod val="103000"/>
+                <a:lumMod val="102000"/>
+                <a:tint val="94000"/>
+              </a:schemeClr>
+            </a:gs>
+            <a:gs pos="50000">
+              <a:schemeClr val="phClr">
+                <a:satMod val="110000"/>
+                <a:lumMod val="100000"/>
+                <a:shade val="100000"/>
+              </a:schemeClr>
+            </a:gs>
+            <a:gs pos="100000">
+              <a:schemeClr val="phClr">
+                <a:lumMod val="99000"/>
+                <a:satMod val="120000"/>
+                <a:shade val="78000"/>
+              </a:schemeClr>
+            </a:gs>
+          </a:gsLst>
+          <a:lin ang="5400000" scaled="0"/>
+        </a:gradFill>
+      </a:fillStyleLst>
+      <a:lnStyleLst>
+        <a:ln w="12700" cap="flat" cmpd="sng" algn="ctr">
+          <a:solidFill>
+            <a:schemeClr val="phClr"/>
+          </a:solidFill>
+          <a:prstDash val="solid"/>
+          <a:miter lim="800000"/>
+        </a:ln>
+        <a:ln w="19050" cap="flat" cmpd="sng" algn="ctr">
+          <a:solidFill>
+            <a:schemeClr val="phClr"/>
+          </a:solidFill>
+          <a:prstDash val="solid"/>
+          <a:miter lim="800000"/>
+        </a:ln>
+        <a:ln w="25400" cap="flat" cmpd="sng" algn="ctr">
+          <a:solidFill>
+            <a:schemeClr val="phClr"/>
+          </a:solidFill>
+          <a:prstDash val="solid"/>
+          <a:miter lim="800000"/>
+        </a:ln>
+      </a:lnStyleLst>
+      <a:effectStyleLst>
+        <a:effectStyle>
+          <a:effectLst/>
+        </a:effectStyle>
+        <a:effectStyle>
+          <a:effectLst/>
+        </a:effectStyle>
+        <a:effectStyle>
+          <a:effectLst>
+            <a:outerShdw blurRad="57150" dist="19050" dir="5400000" algn="ctr" rotWithShape="0">
+              <a:srgbClr val="000000">
+                <a:alpha val="63000"/>
+              </a:srgbClr>
+            </a:outerShdw>
+          </a:effectLst>
+        </a:effectStyle>
+      </a:effectStyleLst>
+      <a:bgFillStyleLst>
+        <a:solidFill>
+          <a:schemeClr val="phClr"/>
+        </a:solidFill>
+        <a:solidFill>
+          <a:schemeClr val="phClr">
+            <a:tint val="95000"/>
+            <a:satMod val="170000"/>
+          </a:schemeClr>
+        </a:solidFill>
+        <a:gradFill rotWithShape="1">
+          <a:gsLst>
+            <a:gs pos="0">
+              <a:schemeClr val="phClr">
+                <a:tint val="93000"/>
+                <a:satMod val="150000"/>
+                <a:shade val="98000"/>
+                <a:lumMod val="102000"/>
+              </a:schemeClr>
+            </a:gs>
+            <a:gs pos="50000">
+              <a:schemeClr val="phClr">
+                <a:tint val="98000"/>
+                <a:satMod val="130000"/>
+                <a:shade val="90000"/>
+                <a:lumMod val="103000"/>
+              </a:schemeClr>
+            </a:gs>
+            <a:gs pos="100000">
+              <a:schemeClr val="phClr">
+                <a:shade val="63000"/>
+                <a:satMod val="120000"/>
+              </a:schemeClr>
+            </a:gs>
+          </a:gsLst>
+          <a:lin ang="5400000" scaled="0"/>
+        </a:gradFill>
+      </a:bgFillStyleLst>
+    </a:fmtScheme>
+  </a:themeElements>
+  <a:objectDefaults>
+    <a:lnDef>
+      <a:spPr/>
+      <a:bodyPr/>
+      <a:lstStyle/>
+      <a:style>
+        <a:lnRef idx="2">
+          <a:schemeClr val="accent1"/>
+        </a:lnRef>
+        <a:fillRef idx="0">
+          <a:schemeClr val="accent1"/>
+        </a:fillRef>
+        <a:effectRef idx="1">
+          <a:schemeClr val="accent1"/>
+        </a:effectRef>
+        <a:fontRef idx="minor">
+          <a:schemeClr val="tx1"/>
+        </a:fontRef>
+      </a:style>
+    </a:lnDef>
+  </a:objectDefaults>
+  <a:extraClrSchemeLst/>
+  <a:extLst>
+    <a:ext uri="{05A4C25C-085E-4340-85A3-A5531E510DB2}">
+      <thm15:themeFamily xmlns:thm15="http://schemas.microsoft.com/office/thememl/2012/main" name="Office Theme" id="{2E142A2C-CD16-42D6-873A-C26D2A0506FA}" vid="{1BDDFF52-6CD6-40A5-AB3C-68EB2F1E4D0A}"/>
+    </a:ext>
+  </a:extLst>
+</a:theme>
 </file>
</xml_diff>